<commit_message>
feat: slides en lenguaje natural + imagen del grafo en slide 5
</commit_message>
<xml_diff>
--- a/Proyecto_PDA_Esgrima.pptx
+++ b/Proyecto_PDA_Esgrima.pptx
@@ -1844,17 +1844,17 @@
               <a:buNone/>
             </a:pPr>
             <a:r>
-              <a:rPr lang="en-US" sz="1200" dirty="0">
+              <a:rPr lang="en-US" sz="1250" dirty="0">
                 <a:solidFill>
                   <a:srgbClr val="E0E0E0"/>
                 </a:solidFill>
-                <a:latin typeface="Courier New" pitchFamily="34" charset="0"/>
-                <a:ea typeface="Courier New" pitchFamily="34" charset="-122"/>
-                <a:cs typeface="Courier New" pitchFamily="34" charset="-120"/>
-              </a:rPr>
-              <a:t>Esgrima (Florete) — combate entre dos tiradores</a:t>
-            </a:r>
-            <a:endParaRPr lang="en-US" sz="1200" dirty="0"/>
+                <a:latin typeface="Calibri" pitchFamily="34" charset="0"/>
+                <a:ea typeface="Calibri" pitchFamily="34" charset="-122"/>
+                <a:cs typeface="Calibri" pitchFamily="34" charset="-120"/>
+              </a:rPr>
+              <a:t>Esgrima (Florete)</a:t>
+            </a:r>
+            <a:endParaRPr lang="en-US" sz="1250" dirty="0"/>
           </a:p>
         </p:txBody>
       </p:sp>
@@ -1945,17 +1945,17 @@
               <a:buNone/>
             </a:pPr>
             <a:r>
-              <a:rPr lang="en-US" sz="1200" dirty="0">
+              <a:rPr lang="en-US" sz="1250" dirty="0">
                 <a:solidFill>
                   <a:srgbClr val="E0E0E0"/>
                 </a:solidFill>
-                <a:latin typeface="Courier New" pitchFamily="34" charset="0"/>
-                <a:ea typeface="Courier New" pitchFamily="34" charset="-122"/>
-                <a:cs typeface="Courier New" pitchFamily="34" charset="-120"/>
-              </a:rPr>
-              <a:t>PDA = (Q, Σ, Γ, δ, q₀, Z₀, F)</a:t>
-            </a:r>
-            <a:endParaRPr lang="en-US" sz="1200" dirty="0"/>
+                <a:latin typeface="Calibri" pitchFamily="34" charset="0"/>
+                <a:ea typeface="Calibri" pitchFamily="34" charset="-122"/>
+                <a:cs typeface="Calibri" pitchFamily="34" charset="-120"/>
+              </a:rPr>
+              <a:t>Autómata Apilador — PDA</a:t>
+            </a:r>
+            <a:endParaRPr lang="en-US" sz="1250" dirty="0"/>
           </a:p>
         </p:txBody>
       </p:sp>
@@ -2046,17 +2046,17 @@
               <a:buNone/>
             </a:pPr>
             <a:r>
-              <a:rPr lang="en-US" sz="1200" dirty="0">
+              <a:rPr lang="en-US" sz="1250" dirty="0">
                 <a:solidFill>
                   <a:srgbClr val="E0E0E0"/>
                 </a:solidFill>
-                <a:latin typeface="Courier New" pitchFamily="34" charset="0"/>
-                <a:ea typeface="Courier New" pitchFamily="34" charset="-122"/>
-                <a:cs typeface="Courier New" pitchFamily="34" charset="-120"/>
-              </a:rPr>
-              <a:t>Q = { q_a,  q_d,  q_v }</a:t>
-            </a:r>
-            <a:endParaRPr lang="en-US" sz="1200" dirty="0"/>
+                <a:latin typeface="Calibri" pitchFamily="34" charset="0"/>
+                <a:ea typeface="Calibri" pitchFamily="34" charset="-122"/>
+                <a:cs typeface="Calibri" pitchFamily="34" charset="-120"/>
+              </a:rPr>
+              <a:t>Ataque  /  Defensa  /  Victoria</a:t>
+            </a:r>
+            <a:endParaRPr lang="en-US" sz="1250" dirty="0"/>
           </a:p>
         </p:txBody>
       </p:sp>
@@ -2116,7 +2116,7 @@
                 <a:ea typeface="Calibri" pitchFamily="34" charset="-122"/>
                 <a:cs typeface="Calibri" pitchFamily="34" charset="-120"/>
               </a:rPr>
-              <a:t>Pila Γ:</a:t>
+              <a:t>Pila:</a:t>
             </a:r>
             <a:endParaRPr lang="en-US" sz="1150" dirty="0"/>
           </a:p>
@@ -2147,17 +2147,17 @@
               <a:buNone/>
             </a:pPr>
             <a:r>
-              <a:rPr lang="en-US" sz="1200" dirty="0">
+              <a:rPr lang="en-US" sz="1250" dirty="0">
                 <a:solidFill>
                   <a:srgbClr val="E0E0E0"/>
                 </a:solidFill>
-                <a:latin typeface="Courier New" pitchFamily="34" charset="0"/>
-                <a:ea typeface="Courier New" pitchFamily="34" charset="-122"/>
-                <a:cs typeface="Courier New" pitchFamily="34" charset="-120"/>
-              </a:rPr>
-              <a:t>{ G, L, M, C, CC } — 5 posiciones de combate</a:t>
-            </a:r>
-            <a:endParaRPr lang="en-US" sz="1200" dirty="0"/>
+                <a:latin typeface="Calibri" pitchFamily="34" charset="0"/>
+                <a:ea typeface="Calibri" pitchFamily="34" charset="-122"/>
+                <a:cs typeface="Calibri" pitchFamily="34" charset="-120"/>
+              </a:rPr>
+              <a:t>5 posiciones de combate</a:t>
+            </a:r>
+            <a:endParaRPr lang="en-US" sz="1250" dirty="0"/>
           </a:p>
         </p:txBody>
       </p:sp>
@@ -2217,7 +2217,7 @@
                 <a:ea typeface="Calibri" pitchFamily="34" charset="-122"/>
                 <a:cs typeface="Calibri" pitchFamily="34" charset="-120"/>
               </a:rPr>
-              <a:t>Reglas δ:</a:t>
+              <a:t>Reglas:</a:t>
             </a:r>
             <a:endParaRPr lang="en-US" sz="1150" dirty="0"/>
           </a:p>
@@ -2248,17 +2248,17 @@
               <a:buNone/>
             </a:pPr>
             <a:r>
-              <a:rPr lang="en-US" sz="1200" dirty="0">
+              <a:rPr lang="en-US" sz="1250" dirty="0">
                 <a:solidFill>
                   <a:srgbClr val="E0E0E0"/>
                 </a:solidFill>
-                <a:latin typeface="Courier New" pitchFamily="34" charset="0"/>
-                <a:ea typeface="Courier New" pitchFamily="34" charset="-122"/>
-                <a:cs typeface="Courier New" pitchFamily="34" charset="-120"/>
+                <a:latin typeface="Calibri" pitchFamily="34" charset="0"/>
+                <a:ea typeface="Calibri" pitchFamily="34" charset="-122"/>
+                <a:cs typeface="Calibri" pitchFamily="34" charset="-120"/>
               </a:rPr>
               <a:t>13 transiciones formales</a:t>
             </a:r>
-            <a:endParaRPr lang="en-US" sz="1200" dirty="0"/>
+            <a:endParaRPr lang="en-US" sz="1250" dirty="0"/>
           </a:p>
         </p:txBody>
       </p:sp>
@@ -2583,7 +2583,7 @@
                 <a:ea typeface="Calibri" pitchFamily="34" charset="-122"/>
                 <a:cs typeface="Calibri" pitchFamily="34" charset="-120"/>
               </a:rPr>
-              <a:t>Esgrima — ¿por qué es el dominio ideal para este PDA?</a:t>
+              <a:t>Esgrima — ¿por qué es el dominio ideal para este autómata?</a:t>
             </a:r>
             <a:endParaRPr lang="en-US" sz="1250" dirty="0"/>
           </a:p>
@@ -2684,7 +2684,7 @@
                 <a:ea typeface="Calibri" pitchFamily="34" charset="-122"/>
                 <a:cs typeface="Calibri" pitchFamily="34" charset="-120"/>
               </a:rPr>
-              <a:t>Combate de florete entre 2 tiradores: Atacante (A) y Defensor (O)</a:t>
+              <a:t>Combate de florete entre dos tiradores: el Atacante y el Defensor</a:t>
             </a:r>
             <a:endParaRPr lang="en-US" sz="1450" dirty="0"/>
           </a:p>
@@ -2785,7 +2785,7 @@
                 <a:ea typeface="Calibri" pitchFamily="34" charset="-122"/>
                 <a:cs typeface="Calibri" pitchFamily="34" charset="-120"/>
               </a:rPr>
-              <a:t>Solo el Atacante puede ejecutar el tocado → exactamente 1 ganador posible</a:t>
+              <a:t>Solo el Atacante puede ejecutar un tocado — esto garantiza que solo uno puede ganar</a:t>
             </a:r>
             <a:endParaRPr lang="en-US" sz="1450" dirty="0"/>
           </a:p>
@@ -2886,7 +2886,7 @@
                 <a:ea typeface="Calibri" pitchFamily="34" charset="-122"/>
                 <a:cs typeface="Calibri" pitchFamily="34" charset="-120"/>
               </a:rPr>
-              <a:t>Las distancias forman una escalera lineal de 5 posiciones: G → L → M → C → CC</a:t>
+              <a:t>Las distancias forman una escalera de cinco posiciones que se pueden recorrer hacia adelante y hacia atrás</a:t>
             </a:r>
             <a:endParaRPr lang="en-US" sz="1450" dirty="0"/>
           </a:p>
@@ -2987,7 +2987,7 @@
                 <a:ea typeface="Calibri" pitchFamily="34" charset="-122"/>
                 <a:cs typeface="Calibri" pitchFamily="34" charset="-120"/>
               </a:rPr>
-              <a:t>El Defensor solo puede retroceder (retirada) o fallar la parada (parada_fallida)</a:t>
+              <a:t>El Defensor solo puede retroceder o fallar la parada — nunca puede ganar por sus propias acciones</a:t>
             </a:r>
             <a:endParaRPr lang="en-US" sz="1450" dirty="0"/>
           </a:p>
@@ -3088,7 +3088,7 @@
                 <a:ea typeface="Calibri" pitchFamily="34" charset="-122"/>
                 <a:cs typeface="Calibri" pitchFamily="34" charset="-120"/>
               </a:rPr>
-              <a:t>La reversibilidad parcial de posiciones es natural: retirada = retroceder exactamente 1 nivel</a:t>
+              <a:t>Esto hace al dominio ideal: hay dos roles, una escalera de estados, y un solo ganador posible</a:t>
             </a:r>
             <a:endParaRPr lang="en-US" sz="1450" dirty="0"/>
           </a:p>
@@ -3376,7 +3376,7 @@
                 <a:ea typeface="Calibri" pitchFamily="34" charset="-122"/>
                 <a:cs typeface="Calibri" pitchFamily="34" charset="-120"/>
               </a:rPr>
-              <a:t>Definición Formal del PDA</a:t>
+              <a:t>Definición Formal del Autómata</a:t>
             </a:r>
             <a:endParaRPr lang="en-US" sz="2600" dirty="0"/>
           </a:p>
@@ -3415,7 +3415,7 @@
                 <a:ea typeface="Calibri" pitchFamily="34" charset="-122"/>
                 <a:cs typeface="Calibri" pitchFamily="34" charset="-120"/>
               </a:rPr>
-              <a:t>PDA = (Q, Σ, Γ, δ, q₀, Z₀, F)</a:t>
+              <a:t>Los siete componentes que definen completamente el PDA</a:t>
             </a:r>
             <a:endParaRPr lang="en-US" sz="1250" dirty="0"/>
           </a:p>
@@ -3516,7 +3516,7 @@
                 <a:ea typeface="Calibri" pitchFamily="34" charset="-122"/>
                 <a:cs typeface="Calibri" pitchFamily="34" charset="-120"/>
               </a:rPr>
-              <a:t>Q = { q_a, q_d, q_v }    →    ataque (turno A) / defensa (turno O) / victoria (fin)</a:t>
+              <a:t>Q — tres estados: turno del atacante, turno del defensor, y victoria</a:t>
             </a:r>
             <a:endParaRPr lang="en-US" sz="1450" dirty="0"/>
           </a:p>
@@ -3617,7 +3617,7 @@
                 <a:ea typeface="Calibri" pitchFamily="34" charset="-122"/>
                 <a:cs typeface="Calibri" pitchFamily="34" charset="-120"/>
               </a:rPr>
-              <a:t>Σ_A = { avance, tocado }    →    acciones del Atacante</a:t>
+              <a:t>Σ — cuatro acciones: avanzar y hacer tocado para el atacante; retroceder y fallar la parada para el defensor</a:t>
             </a:r>
             <a:endParaRPr lang="en-US" sz="1450" dirty="0"/>
           </a:p>
@@ -3718,7 +3718,7 @@
                 <a:ea typeface="Calibri" pitchFamily="34" charset="-122"/>
                 <a:cs typeface="Calibri" pitchFamily="34" charset="-120"/>
               </a:rPr>
-              <a:t>Σ_O = { retirada, parada_fallida }    →    acciones del Defensor</a:t>
+              <a:t>Γ — cinco símbolos de la pila: las cinco posiciones del combate (En Garde, Largo, Medio, Corto, Corps-à-corps)</a:t>
             </a:r>
             <a:endParaRPr lang="en-US" sz="1450" dirty="0"/>
           </a:p>
@@ -3819,7 +3819,7 @@
                 <a:ea typeface="Calibri" pitchFamily="34" charset="-122"/>
                 <a:cs typeface="Calibri" pitchFamily="34" charset="-120"/>
               </a:rPr>
-              <a:t>Γ = { G, L, M, C, CC }    →    5 símbolos de la pila = 5 posiciones de combate</a:t>
+              <a:t>q₀ y Z₀ — el autómata siempre empieza con el turno del atacante parado en la posición de guardia</a:t>
             </a:r>
             <a:endParaRPr lang="en-US" sz="1450" dirty="0"/>
           </a:p>
@@ -3920,7 +3920,7 @@
                 <a:ea typeface="Calibri" pitchFamily="34" charset="-122"/>
                 <a:cs typeface="Calibri" pitchFamily="34" charset="-120"/>
               </a:rPr>
-              <a:t>q₀ = q_a   |   Z₀ = G   |   F = { q_v }    →    inicio en guardia, acepta por estado final</a:t>
+              <a:t>F — el único estado de aceptación es la victoria, que solo el atacante puede alcanzar</a:t>
             </a:r>
             <a:endParaRPr lang="en-US" sz="1450" dirty="0"/>
           </a:p>
@@ -4208,7 +4208,7 @@
                 <a:ea typeface="Calibri" pitchFamily="34" charset="-122"/>
                 <a:cs typeface="Calibri" pitchFamily="34" charset="-120"/>
               </a:rPr>
-              <a:t>Semántica de la Pila</a:t>
+              <a:t>La Pila — Por qué necesitamos un PDA</a:t>
             </a:r>
             <a:endParaRPr lang="en-US" sz="2600" dirty="0"/>
           </a:p>
@@ -4247,7 +4247,7 @@
                 <a:ea typeface="Calibri" pitchFamily="34" charset="-122"/>
                 <a:cs typeface="Calibri" pitchFamily="34" charset="-120"/>
               </a:rPr>
-              <a:t>Cada acción tiene un efecto concreto y bien definido sobre la pila</a:t>
+              <a:t>¿Por qué no alcanza un autómata finito (AFD)?</a:t>
             </a:r>
             <a:endParaRPr lang="en-US" sz="1250" dirty="0"/>
           </a:p>
@@ -4348,7 +4348,7 @@
                 <a:ea typeface="Calibri" pitchFamily="34" charset="-122"/>
                 <a:cs typeface="Calibri" pitchFamily="34" charset="-120"/>
               </a:rPr>
-              <a:t>PUSH  (avance):  apila la nueva posición encima  →  pila crece con cada avance de A</a:t>
+              <a:t>Cada avance apila la nueva posición — la pila crece y recuerda el historial completo</a:t>
             </a:r>
             <a:endParaRPr lang="en-US" sz="1450" dirty="0"/>
           </a:p>
@@ -4449,7 +4449,7 @@
                 <a:ea typeface="Calibri" pitchFamily="34" charset="-122"/>
                 <a:cs typeface="Calibri" pitchFamily="34" charset="-120"/>
               </a:rPr>
-              <a:t>POP  (retirada):  desapila el tope  →  vuelve exactamente al estado previo, sin importar la profundidad</a:t>
+              <a:t>Cada retirada desapila el tope — el autómata vuelve exactamente a donde estaba antes</a:t>
             </a:r>
             <a:endParaRPr lang="en-US" sz="1450" dirty="0"/>
           </a:p>
@@ -4550,7 +4550,7 @@
                 <a:ea typeface="Calibri" pitchFamily="34" charset="-122"/>
                 <a:cs typeface="Calibri" pitchFamily="34" charset="-120"/>
               </a:rPr>
-              <a:t>NO-OP  (parada_fallida):  no modifica la pila  →  el turno cambia pero la posición queda igual</a:t>
+              <a:t>Una parada fallida no cambia la pila — solo pasa el turno sin mover la posición</a:t>
             </a:r>
             <a:endParaRPr lang="en-US" sz="1450" dirty="0"/>
           </a:p>
@@ -4651,7 +4651,7 @@
                 <a:ea typeface="Calibri" pitchFamily="34" charset="-122"/>
                 <a:cs typeface="Calibri" pitchFamily="34" charset="-120"/>
               </a:rPr>
-              <a:t>¿Por qué PDA y no AFD?  →  el AFD no puede recordar cuántos avances hubo ni a qué posición regresar</a:t>
+              <a:t>Un AFD no tiene memoria: no puede saber a qué posición exacta regresar luego de varias retiradas</a:t>
             </a:r>
             <a:endParaRPr lang="en-US" sz="1450" dirty="0"/>
           </a:p>
@@ -4752,7 +4752,7 @@
                 <a:ea typeface="Calibri" pitchFamily="34" charset="-122"/>
                 <a:cs typeface="Calibri" pitchFamily="34" charset="-120"/>
               </a:rPr>
-              <a:t>La pila hace posible el retroceso exacto: es el componente que justifica formalmente el PDA</a:t>
+              <a:t>La pila resuelve esto — por eso necesitamos un PDA y no un autómata finito</a:t>
             </a:r>
             <a:endParaRPr lang="en-US" sz="1450" dirty="0"/>
           </a:p>
@@ -5071,7 +5071,7 @@
               <a:buNone/>
             </a:pPr>
             <a:r>
-              <a:rPr lang="en-US" sz="1250" i="1" dirty="0">
+              <a:rPr lang="en-US" sz="1200" i="1" dirty="0">
                 <a:solidFill>
                   <a:srgbClr val="A8D8EA"/>
                 </a:solidFill>
@@ -5079,9 +5079,9 @@
                 <a:ea typeface="Calibri" pitchFamily="34" charset="-122"/>
                 <a:cs typeface="Calibri" pitchFamily="34" charset="-120"/>
               </a:rPr>
-              <a:t>Notación de aristas:  símbolo_leído, tope_actual / pila_resultante  |  ε = solo pop</a:t>
-            </a:r>
-            <a:endParaRPr lang="en-US" sz="1250" dirty="0"/>
+              <a:t>Tres estados, cuatro tipos de flechas, un solo camino a la victoria</a:t>
+            </a:r>
+            <a:endParaRPr lang="en-US" sz="1200" dirty="0"/>
           </a:p>
         </p:txBody>
       </p:sp>
@@ -5108,16 +5108,40 @@
           </a:ln>
         </p:spPr>
       </p:sp>
-      <p:sp>
-        <p:nvSpPr>
-          <p:cNvPr id="11" name="Text 9"/>
-          <p:cNvSpPr/>
-          <p:nvPr/>
-        </p:nvSpPr>
-        <p:spPr>
-          <a:xfrm>
-            <a:off x="256032" y="1499616"/>
-            <a:ext cx="320040" cy="859627"/>
+      <p:pic>
+        <p:nvPicPr>
+          <p:cNvPr id="11" name="Image 0" descr="C:\Users\HP Pro\Desktop\automata_proyecto\grafo_pda.png">    </p:cNvPr>
+          <p:cNvPicPr>
+            <a:picLocks noChangeAspect="1"/>
+          </p:cNvPicPr>
+          <p:nvPr/>
+        </p:nvPicPr>
+        <p:blipFill>
+          <a:blip r:embed="rId1"/>
+          <a:stretch>
+            <a:fillRect/>
+          </a:stretch>
+        </p:blipFill>
+        <p:spPr>
+          <a:xfrm>
+            <a:off x="164592" y="1417320"/>
+            <a:ext cx="7132320" cy="5074920"/>
+          </a:xfrm>
+          <a:prstGeom prst="rect">
+            <a:avLst/>
+          </a:prstGeom>
+        </p:spPr>
+      </p:pic>
+      <p:sp>
+        <p:nvSpPr>
+          <p:cNvPr id="12" name="Text 9"/>
+          <p:cNvSpPr/>
+          <p:nvPr/>
+        </p:nvSpPr>
+        <p:spPr>
+          <a:xfrm>
+            <a:off x="7452360" y="1527048"/>
+            <a:ext cx="256032" cy="588482"/>
           </a:xfrm>
           <a:prstGeom prst="rect">
             <a:avLst/>
@@ -5133,7 +5157,7 @@
               <a:buNone/>
             </a:pPr>
             <a:r>
-              <a:rPr lang="en-US" sz="1600" b="1" dirty="0">
+              <a:rPr lang="en-US" sz="1500" b="1" dirty="0">
                 <a:solidFill>
                   <a:srgbClr val="F5A623"/>
                 </a:solidFill>
@@ -5143,20 +5167,20 @@
               </a:rPr>
               <a:t>›</a:t>
             </a:r>
-            <a:endParaRPr lang="en-US" sz="1600" dirty="0"/>
-          </a:p>
-        </p:txBody>
-      </p:sp>
-      <p:sp>
-        <p:nvSpPr>
-          <p:cNvPr id="12" name="Text 10"/>
-          <p:cNvSpPr/>
-          <p:nvPr/>
-        </p:nvSpPr>
-        <p:spPr>
-          <a:xfrm>
-            <a:off x="594360" y="1481328"/>
-            <a:ext cx="11384280" cy="859627"/>
+            <a:endParaRPr lang="en-US" sz="1500" dirty="0"/>
+          </a:p>
+        </p:txBody>
+      </p:sp>
+      <p:sp>
+        <p:nvSpPr>
+          <p:cNvPr id="13" name="Text 10"/>
+          <p:cNvSpPr/>
+          <p:nvPr/>
+        </p:nvSpPr>
+        <p:spPr>
+          <a:xfrm>
+            <a:off x="7726680" y="1508760"/>
+            <a:ext cx="4315968" cy="588482"/>
           </a:xfrm>
           <a:prstGeom prst="rect">
             <a:avLst/>
@@ -5172,7 +5196,7 @@
               <a:buNone/>
             </a:pPr>
             <a:r>
-              <a:rPr lang="en-US" sz="1450" dirty="0">
+              <a:rPr lang="en-US" sz="1300" dirty="0">
                 <a:solidFill>
                   <a:srgbClr val="E0E0E0"/>
                 </a:solidFill>
@@ -5180,22 +5204,22 @@
                 <a:ea typeface="Calibri" pitchFamily="34" charset="-122"/>
                 <a:cs typeface="Calibri" pitchFamily="34" charset="-120"/>
               </a:rPr>
-              <a:t>q_a  (turno del Atacante)  →  estado inicial, recibe: avance o tocado</a:t>
-            </a:r>
-            <a:endParaRPr lang="en-US" sz="1450" dirty="0"/>
-          </a:p>
-        </p:txBody>
-      </p:sp>
-      <p:sp>
-        <p:nvSpPr>
-          <p:cNvPr id="13" name="Shape 11"/>
-          <p:cNvSpPr/>
-          <p:nvPr/>
-        </p:nvSpPr>
-        <p:spPr>
-          <a:xfrm>
-            <a:off x="594360" y="2391522"/>
-            <a:ext cx="11384280" cy="0"/>
+              <a:t>q_a — turno del atacante (estado inicial)</a:t>
+            </a:r>
+            <a:endParaRPr lang="en-US" sz="1300" dirty="0"/>
+          </a:p>
+        </p:txBody>
+      </p:sp>
+      <p:sp>
+        <p:nvSpPr>
+          <p:cNvPr id="14" name="Shape 11"/>
+          <p:cNvSpPr/>
+          <p:nvPr/>
+        </p:nvSpPr>
+        <p:spPr>
+          <a:xfrm>
+            <a:off x="7589520" y="2131858"/>
+            <a:ext cx="4434840" cy="0"/>
           </a:xfrm>
           <a:prstGeom prst="line">
             <a:avLst/>
@@ -5211,14 +5235,14 @@
       </p:sp>
       <p:sp>
         <p:nvSpPr>
-          <p:cNvPr id="14" name="Text 12"/>
-          <p:cNvSpPr/>
-          <p:nvPr/>
-        </p:nvSpPr>
-        <p:spPr>
-          <a:xfrm>
-            <a:off x="256032" y="2510942"/>
-            <a:ext cx="320040" cy="859627"/>
+          <p:cNvPr id="15" name="Text 12"/>
+          <p:cNvSpPr/>
+          <p:nvPr/>
+        </p:nvSpPr>
+        <p:spPr>
+          <a:xfrm>
+            <a:off x="7452360" y="2219379"/>
+            <a:ext cx="256032" cy="588482"/>
           </a:xfrm>
           <a:prstGeom prst="rect">
             <a:avLst/>
@@ -5234,7 +5258,7 @@
               <a:buNone/>
             </a:pPr>
             <a:r>
-              <a:rPr lang="en-US" sz="1600" b="1" dirty="0">
+              <a:rPr lang="en-US" sz="1500" b="1" dirty="0">
                 <a:solidFill>
                   <a:srgbClr val="F5A623"/>
                 </a:solidFill>
@@ -5244,20 +5268,20 @@
               </a:rPr>
               <a:t>›</a:t>
             </a:r>
-            <a:endParaRPr lang="en-US" sz="1600" dirty="0"/>
-          </a:p>
-        </p:txBody>
-      </p:sp>
-      <p:sp>
-        <p:nvSpPr>
-          <p:cNvPr id="15" name="Text 13"/>
-          <p:cNvSpPr/>
-          <p:nvPr/>
-        </p:nvSpPr>
-        <p:spPr>
-          <a:xfrm>
-            <a:off x="594360" y="2492654"/>
-            <a:ext cx="11384280" cy="859627"/>
+            <a:endParaRPr lang="en-US" sz="1500" dirty="0"/>
+          </a:p>
+        </p:txBody>
+      </p:sp>
+      <p:sp>
+        <p:nvSpPr>
+          <p:cNvPr id="16" name="Text 13"/>
+          <p:cNvSpPr/>
+          <p:nvPr/>
+        </p:nvSpPr>
+        <p:spPr>
+          <a:xfrm>
+            <a:off x="7726680" y="2201091"/>
+            <a:ext cx="4315968" cy="588482"/>
           </a:xfrm>
           <a:prstGeom prst="rect">
             <a:avLst/>
@@ -5273,7 +5297,7 @@
               <a:buNone/>
             </a:pPr>
             <a:r>
-              <a:rPr lang="en-US" sz="1450" dirty="0">
+              <a:rPr lang="en-US" sz="1300" dirty="0">
                 <a:solidFill>
                   <a:srgbClr val="E0E0E0"/>
                 </a:solidFill>
@@ -5281,22 +5305,22 @@
                 <a:ea typeface="Calibri" pitchFamily="34" charset="-122"/>
                 <a:cs typeface="Calibri" pitchFamily="34" charset="-120"/>
               </a:rPr>
-              <a:t>q_d  (turno del Defensor)  →  recibe: retirada o parada_fallida, siempre vuelve a q_a</a:t>
-            </a:r>
-            <a:endParaRPr lang="en-US" sz="1450" dirty="0"/>
-          </a:p>
-        </p:txBody>
-      </p:sp>
-      <p:sp>
-        <p:nvSpPr>
-          <p:cNvPr id="16" name="Shape 14"/>
-          <p:cNvSpPr/>
-          <p:nvPr/>
-        </p:nvSpPr>
-        <p:spPr>
-          <a:xfrm>
-            <a:off x="594360" y="3402848"/>
-            <a:ext cx="11384280" cy="0"/>
+              <a:t>q_d — turno del defensor</a:t>
+            </a:r>
+            <a:endParaRPr lang="en-US" sz="1300" dirty="0"/>
+          </a:p>
+        </p:txBody>
+      </p:sp>
+      <p:sp>
+        <p:nvSpPr>
+          <p:cNvPr id="17" name="Shape 14"/>
+          <p:cNvSpPr/>
+          <p:nvPr/>
+        </p:nvSpPr>
+        <p:spPr>
+          <a:xfrm>
+            <a:off x="7589520" y="2824190"/>
+            <a:ext cx="4434840" cy="0"/>
           </a:xfrm>
           <a:prstGeom prst="line">
             <a:avLst/>
@@ -5312,14 +5336,14 @@
       </p:sp>
       <p:sp>
         <p:nvSpPr>
-          <p:cNvPr id="17" name="Text 15"/>
-          <p:cNvSpPr/>
-          <p:nvPr/>
-        </p:nvSpPr>
-        <p:spPr>
-          <a:xfrm>
-            <a:off x="256032" y="3522269"/>
-            <a:ext cx="320040" cy="859627"/>
+          <p:cNvPr id="18" name="Text 15"/>
+          <p:cNvSpPr/>
+          <p:nvPr/>
+        </p:nvSpPr>
+        <p:spPr>
+          <a:xfrm>
+            <a:off x="7452360" y="2911711"/>
+            <a:ext cx="256032" cy="588482"/>
           </a:xfrm>
           <a:prstGeom prst="rect">
             <a:avLst/>
@@ -5335,7 +5359,7 @@
               <a:buNone/>
             </a:pPr>
             <a:r>
-              <a:rPr lang="en-US" sz="1600" b="1" dirty="0">
+              <a:rPr lang="en-US" sz="1500" b="1" dirty="0">
                 <a:solidFill>
                   <a:srgbClr val="F5A623"/>
                 </a:solidFill>
@@ -5345,20 +5369,20 @@
               </a:rPr>
               <a:t>›</a:t>
             </a:r>
-            <a:endParaRPr lang="en-US" sz="1600" dirty="0"/>
-          </a:p>
-        </p:txBody>
-      </p:sp>
-      <p:sp>
-        <p:nvSpPr>
-          <p:cNvPr id="18" name="Text 16"/>
-          <p:cNvSpPr/>
-          <p:nvPr/>
-        </p:nvSpPr>
-        <p:spPr>
-          <a:xfrm>
-            <a:off x="594360" y="3503981"/>
-            <a:ext cx="11384280" cy="859627"/>
+            <a:endParaRPr lang="en-US" sz="1500" dirty="0"/>
+          </a:p>
+        </p:txBody>
+      </p:sp>
+      <p:sp>
+        <p:nvSpPr>
+          <p:cNvPr id="19" name="Text 16"/>
+          <p:cNvSpPr/>
+          <p:nvPr/>
+        </p:nvSpPr>
+        <p:spPr>
+          <a:xfrm>
+            <a:off x="7726680" y="2893423"/>
+            <a:ext cx="4315968" cy="588482"/>
           </a:xfrm>
           <a:prstGeom prst="rect">
             <a:avLst/>
@@ -5374,7 +5398,7 @@
               <a:buNone/>
             </a:pPr>
             <a:r>
-              <a:rPr lang="en-US" sz="1450" dirty="0">
+              <a:rPr lang="en-US" sz="1300" dirty="0">
                 <a:solidFill>
                   <a:srgbClr val="E0E0E0"/>
                 </a:solidFill>
@@ -5382,22 +5406,22 @@
                 <a:ea typeface="Calibri" pitchFamily="34" charset="-122"/>
                 <a:cs typeface="Calibri" pitchFamily="34" charset="-120"/>
               </a:rPr>
-              <a:t>q_v  (victoria)  →  estado de aceptación, doble círculo, solo alcanzable con tocado desde CC</a:t>
-            </a:r>
-            <a:endParaRPr lang="en-US" sz="1450" dirty="0"/>
-          </a:p>
-        </p:txBody>
-      </p:sp>
-      <p:sp>
-        <p:nvSpPr>
-          <p:cNvPr id="19" name="Shape 17"/>
-          <p:cNvSpPr/>
-          <p:nvPr/>
-        </p:nvSpPr>
-        <p:spPr>
-          <a:xfrm>
-            <a:off x="594360" y="4414175"/>
-            <a:ext cx="11384280" cy="0"/>
+              <a:t>q_v — victoria (doble círculo = acepta)</a:t>
+            </a:r>
+            <a:endParaRPr lang="en-US" sz="1300" dirty="0"/>
+          </a:p>
+        </p:txBody>
+      </p:sp>
+      <p:sp>
+        <p:nvSpPr>
+          <p:cNvPr id="20" name="Shape 17"/>
+          <p:cNvSpPr/>
+          <p:nvPr/>
+        </p:nvSpPr>
+        <p:spPr>
+          <a:xfrm>
+            <a:off x="7589520" y="3516521"/>
+            <a:ext cx="4434840" cy="0"/>
           </a:xfrm>
           <a:prstGeom prst="line">
             <a:avLst/>
@@ -5413,14 +5437,14 @@
       </p:sp>
       <p:sp>
         <p:nvSpPr>
-          <p:cNvPr id="20" name="Text 18"/>
-          <p:cNvSpPr/>
-          <p:nvPr/>
-        </p:nvSpPr>
-        <p:spPr>
-          <a:xfrm>
-            <a:off x="256032" y="4533595"/>
-            <a:ext cx="320040" cy="859627"/>
+          <p:cNvPr id="21" name="Text 18"/>
+          <p:cNvSpPr/>
+          <p:nvPr/>
+        </p:nvSpPr>
+        <p:spPr>
+          <a:xfrm>
+            <a:off x="7452360" y="3604042"/>
+            <a:ext cx="256032" cy="588482"/>
           </a:xfrm>
           <a:prstGeom prst="rect">
             <a:avLst/>
@@ -5436,7 +5460,7 @@
               <a:buNone/>
             </a:pPr>
             <a:r>
-              <a:rPr lang="en-US" sz="1600" b="1" dirty="0">
+              <a:rPr lang="en-US" sz="1500" b="1" dirty="0">
                 <a:solidFill>
                   <a:srgbClr val="F5A623"/>
                 </a:solidFill>
@@ -5446,20 +5470,20 @@
               </a:rPr>
               <a:t>›</a:t>
             </a:r>
-            <a:endParaRPr lang="en-US" sz="1600" dirty="0"/>
-          </a:p>
-        </p:txBody>
-      </p:sp>
-      <p:sp>
-        <p:nvSpPr>
-          <p:cNvPr id="21" name="Text 19"/>
-          <p:cNvSpPr/>
-          <p:nvPr/>
-        </p:nvSpPr>
-        <p:spPr>
-          <a:xfrm>
-            <a:off x="594360" y="4515307"/>
-            <a:ext cx="11384280" cy="859627"/>
+            <a:endParaRPr lang="en-US" sz="1500" dirty="0"/>
+          </a:p>
+        </p:txBody>
+      </p:sp>
+      <p:sp>
+        <p:nvSpPr>
+          <p:cNvPr id="22" name="Text 19"/>
+          <p:cNvSpPr/>
+          <p:nvPr/>
+        </p:nvSpPr>
+        <p:spPr>
+          <a:xfrm>
+            <a:off x="7726680" y="3585754"/>
+            <a:ext cx="4315968" cy="588482"/>
           </a:xfrm>
           <a:prstGeom prst="rect">
             <a:avLst/>
@@ -5475,7 +5499,7 @@
               <a:buNone/>
             </a:pPr>
             <a:r>
-              <a:rPr lang="en-US" sz="1450" dirty="0">
+              <a:rPr lang="en-US" sz="1300" dirty="0">
                 <a:solidFill>
                   <a:srgbClr val="E0E0E0"/>
                 </a:solidFill>
@@ -5483,22 +5507,22 @@
                 <a:ea typeface="Calibri" pitchFamily="34" charset="-122"/>
                 <a:cs typeface="Calibri" pitchFamily="34" charset="-120"/>
               </a:rPr>
-              <a:t>Flecha azul  q_a → q_d:  avance + PUSH  |  Flecha roja  q_d → q_a:  retirada + POP</a:t>
-            </a:r>
-            <a:endParaRPr lang="en-US" sz="1450" dirty="0"/>
-          </a:p>
-        </p:txBody>
-      </p:sp>
-      <p:sp>
-        <p:nvSpPr>
-          <p:cNvPr id="22" name="Shape 20"/>
-          <p:cNvSpPr/>
-          <p:nvPr/>
-        </p:nvSpPr>
-        <p:spPr>
-          <a:xfrm>
-            <a:off x="594360" y="5425501"/>
-            <a:ext cx="11384280" cy="0"/>
+              <a:t>Azul: el atacante avanza y apila</a:t>
+            </a:r>
+            <a:endParaRPr lang="en-US" sz="1300" dirty="0"/>
+          </a:p>
+        </p:txBody>
+      </p:sp>
+      <p:sp>
+        <p:nvSpPr>
+          <p:cNvPr id="23" name="Shape 20"/>
+          <p:cNvSpPr/>
+          <p:nvPr/>
+        </p:nvSpPr>
+        <p:spPr>
+          <a:xfrm>
+            <a:off x="7589520" y="4208853"/>
+            <a:ext cx="4434840" cy="0"/>
           </a:xfrm>
           <a:prstGeom prst="line">
             <a:avLst/>
@@ -5514,14 +5538,14 @@
       </p:sp>
       <p:sp>
         <p:nvSpPr>
-          <p:cNvPr id="23" name="Text 21"/>
-          <p:cNvSpPr/>
-          <p:nvPr/>
-        </p:nvSpPr>
-        <p:spPr>
-          <a:xfrm>
-            <a:off x="256032" y="5544922"/>
-            <a:ext cx="320040" cy="859627"/>
+          <p:cNvPr id="24" name="Text 21"/>
+          <p:cNvSpPr/>
+          <p:nvPr/>
+        </p:nvSpPr>
+        <p:spPr>
+          <a:xfrm>
+            <a:off x="7452360" y="4296374"/>
+            <a:ext cx="256032" cy="588482"/>
           </a:xfrm>
           <a:prstGeom prst="rect">
             <a:avLst/>
@@ -5537,7 +5561,7 @@
               <a:buNone/>
             </a:pPr>
             <a:r>
-              <a:rPr lang="en-US" sz="1600" b="1" dirty="0">
+              <a:rPr lang="en-US" sz="1500" b="1" dirty="0">
                 <a:solidFill>
                   <a:srgbClr val="F5A623"/>
                 </a:solidFill>
@@ -5547,20 +5571,20 @@
               </a:rPr>
               <a:t>›</a:t>
             </a:r>
-            <a:endParaRPr lang="en-US" sz="1600" dirty="0"/>
-          </a:p>
-        </p:txBody>
-      </p:sp>
-      <p:sp>
-        <p:nvSpPr>
-          <p:cNvPr id="24" name="Text 22"/>
-          <p:cNvSpPr/>
-          <p:nvPr/>
-        </p:nvSpPr>
-        <p:spPr>
-          <a:xfrm>
-            <a:off x="594360" y="5526634"/>
-            <a:ext cx="11384280" cy="859627"/>
+            <a:endParaRPr lang="en-US" sz="1500" dirty="0"/>
+          </a:p>
+        </p:txBody>
+      </p:sp>
+      <p:sp>
+        <p:nvSpPr>
+          <p:cNvPr id="25" name="Text 22"/>
+          <p:cNvSpPr/>
+          <p:nvPr/>
+        </p:nvSpPr>
+        <p:spPr>
+          <a:xfrm>
+            <a:off x="7726680" y="4278086"/>
+            <a:ext cx="4315968" cy="588482"/>
           </a:xfrm>
           <a:prstGeom prst="rect">
             <a:avLst/>
@@ -5576,7 +5600,7 @@
               <a:buNone/>
             </a:pPr>
             <a:r>
-              <a:rPr lang="en-US" sz="1450" dirty="0">
+              <a:rPr lang="en-US" sz="1300" dirty="0">
                 <a:solidFill>
                   <a:srgbClr val="E0E0E0"/>
                 </a:solidFill>
@@ -5584,15 +5608,217 @@
                 <a:ea typeface="Calibri" pitchFamily="34" charset="-122"/>
                 <a:cs typeface="Calibri" pitchFamily="34" charset="-120"/>
               </a:rPr>
-              <a:t>Flecha dorada  q_a → q_v:  tocado, CC / CC  (el único camino a la victoria)</a:t>
-            </a:r>
-            <a:endParaRPr lang="en-US" sz="1450" dirty="0"/>
-          </a:p>
-        </p:txBody>
-      </p:sp>
-      <p:sp>
-        <p:nvSpPr>
-          <p:cNvPr id="25" name="Shape 23"/>
+              <a:t>Rojo: el defensor retrocede y desapila</a:t>
+            </a:r>
+            <a:endParaRPr lang="en-US" sz="1300" dirty="0"/>
+          </a:p>
+        </p:txBody>
+      </p:sp>
+      <p:sp>
+        <p:nvSpPr>
+          <p:cNvPr id="26" name="Shape 23"/>
+          <p:cNvSpPr/>
+          <p:nvPr/>
+        </p:nvSpPr>
+        <p:spPr>
+          <a:xfrm>
+            <a:off x="7589520" y="4901184"/>
+            <a:ext cx="4434840" cy="0"/>
+          </a:xfrm>
+          <a:prstGeom prst="line">
+            <a:avLst/>
+          </a:prstGeom>
+          <a:noFill/>
+          <a:ln w="5080">
+            <a:solidFill>
+              <a:srgbClr val="0F3460"/>
+            </a:solidFill>
+            <a:prstDash val="solid"/>
+          </a:ln>
+        </p:spPr>
+      </p:sp>
+      <p:sp>
+        <p:nvSpPr>
+          <p:cNvPr id="27" name="Text 24"/>
+          <p:cNvSpPr/>
+          <p:nvPr/>
+        </p:nvSpPr>
+        <p:spPr>
+          <a:xfrm>
+            <a:off x="7452360" y="4988705"/>
+            <a:ext cx="256032" cy="588482"/>
+          </a:xfrm>
+          <a:prstGeom prst="rect">
+            <a:avLst/>
+          </a:prstGeom>
+          <a:noFill/>
+          <a:ln/>
+        </p:spPr>
+        <p:txBody>
+          <a:bodyPr wrap="square" rtlCol="0" anchor="t"/>
+          <a:lstStyle/>
+          <a:p>
+            <a:pPr indent="0" marL="0">
+              <a:buNone/>
+            </a:pPr>
+            <a:r>
+              <a:rPr lang="en-US" sz="1500" b="1" dirty="0">
+                <a:solidFill>
+                  <a:srgbClr val="F5A623"/>
+                </a:solidFill>
+                <a:latin typeface="Calibri" pitchFamily="34" charset="0"/>
+                <a:ea typeface="Calibri" pitchFamily="34" charset="-122"/>
+                <a:cs typeface="Calibri" pitchFamily="34" charset="-120"/>
+              </a:rPr>
+              <a:t>›</a:t>
+            </a:r>
+            <a:endParaRPr lang="en-US" sz="1500" dirty="0"/>
+          </a:p>
+        </p:txBody>
+      </p:sp>
+      <p:sp>
+        <p:nvSpPr>
+          <p:cNvPr id="28" name="Text 25"/>
+          <p:cNvSpPr/>
+          <p:nvPr/>
+        </p:nvSpPr>
+        <p:spPr>
+          <a:xfrm>
+            <a:off x="7726680" y="4970417"/>
+            <a:ext cx="4315968" cy="588482"/>
+          </a:xfrm>
+          <a:prstGeom prst="rect">
+            <a:avLst/>
+          </a:prstGeom>
+          <a:noFill/>
+          <a:ln/>
+        </p:spPr>
+        <p:txBody>
+          <a:bodyPr wrap="square" rtlCol="0" anchor="t"/>
+          <a:lstStyle/>
+          <a:p>
+            <a:pPr indent="0" marL="0">
+              <a:buNone/>
+            </a:pPr>
+            <a:r>
+              <a:rPr lang="en-US" sz="1300" dirty="0">
+                <a:solidFill>
+                  <a:srgbClr val="E0E0E0"/>
+                </a:solidFill>
+                <a:latin typeface="Calibri" pitchFamily="34" charset="0"/>
+                <a:ea typeface="Calibri" pitchFamily="34" charset="-122"/>
+                <a:cs typeface="Calibri" pitchFamily="34" charset="-120"/>
+              </a:rPr>
+              <a:t>Punteado: parada fallida, nada cambia</a:t>
+            </a:r>
+            <a:endParaRPr lang="en-US" sz="1300" dirty="0"/>
+          </a:p>
+        </p:txBody>
+      </p:sp>
+      <p:sp>
+        <p:nvSpPr>
+          <p:cNvPr id="29" name="Shape 26"/>
+          <p:cNvSpPr/>
+          <p:nvPr/>
+        </p:nvSpPr>
+        <p:spPr>
+          <a:xfrm>
+            <a:off x="7589520" y="5593515"/>
+            <a:ext cx="4434840" cy="0"/>
+          </a:xfrm>
+          <a:prstGeom prst="line">
+            <a:avLst/>
+          </a:prstGeom>
+          <a:noFill/>
+          <a:ln w="5080">
+            <a:solidFill>
+              <a:srgbClr val="0F3460"/>
+            </a:solidFill>
+            <a:prstDash val="solid"/>
+          </a:ln>
+        </p:spPr>
+      </p:sp>
+      <p:sp>
+        <p:nvSpPr>
+          <p:cNvPr id="30" name="Text 27"/>
+          <p:cNvSpPr/>
+          <p:nvPr/>
+        </p:nvSpPr>
+        <p:spPr>
+          <a:xfrm>
+            <a:off x="7452360" y="5681037"/>
+            <a:ext cx="256032" cy="588482"/>
+          </a:xfrm>
+          <a:prstGeom prst="rect">
+            <a:avLst/>
+          </a:prstGeom>
+          <a:noFill/>
+          <a:ln/>
+        </p:spPr>
+        <p:txBody>
+          <a:bodyPr wrap="square" rtlCol="0" anchor="t"/>
+          <a:lstStyle/>
+          <a:p>
+            <a:pPr indent="0" marL="0">
+              <a:buNone/>
+            </a:pPr>
+            <a:r>
+              <a:rPr lang="en-US" sz="1500" b="1" dirty="0">
+                <a:solidFill>
+                  <a:srgbClr val="F5A623"/>
+                </a:solidFill>
+                <a:latin typeface="Calibri" pitchFamily="34" charset="0"/>
+                <a:ea typeface="Calibri" pitchFamily="34" charset="-122"/>
+                <a:cs typeface="Calibri" pitchFamily="34" charset="-120"/>
+              </a:rPr>
+              <a:t>›</a:t>
+            </a:r>
+            <a:endParaRPr lang="en-US" sz="1500" dirty="0"/>
+          </a:p>
+        </p:txBody>
+      </p:sp>
+      <p:sp>
+        <p:nvSpPr>
+          <p:cNvPr id="31" name="Text 28"/>
+          <p:cNvSpPr/>
+          <p:nvPr/>
+        </p:nvSpPr>
+        <p:spPr>
+          <a:xfrm>
+            <a:off x="7726680" y="5662749"/>
+            <a:ext cx="4315968" cy="588482"/>
+          </a:xfrm>
+          <a:prstGeom prst="rect">
+            <a:avLst/>
+          </a:prstGeom>
+          <a:noFill/>
+          <a:ln/>
+        </p:spPr>
+        <p:txBody>
+          <a:bodyPr wrap="square" rtlCol="0" anchor="t"/>
+          <a:lstStyle/>
+          <a:p>
+            <a:pPr indent="0" marL="0">
+              <a:buNone/>
+            </a:pPr>
+            <a:r>
+              <a:rPr lang="en-US" sz="1300" dirty="0">
+                <a:solidFill>
+                  <a:srgbClr val="E0E0E0"/>
+                </a:solidFill>
+                <a:latin typeface="Calibri" pitchFamily="34" charset="0"/>
+                <a:ea typeface="Calibri" pitchFamily="34" charset="-122"/>
+                <a:cs typeface="Calibri" pitchFamily="34" charset="-120"/>
+              </a:rPr>
+              <a:t>Dorado: tocado desde la posición más cercana — única forma de ganar</a:t>
+            </a:r>
+            <a:endParaRPr lang="en-US" sz="1300" dirty="0"/>
+          </a:p>
+        </p:txBody>
+      </p:sp>
+      <p:sp>
+        <p:nvSpPr>
+          <p:cNvPr id="32" name="Shape 29"/>
           <p:cNvSpPr/>
           <p:nvPr/>
         </p:nvSpPr>
@@ -5612,7 +5838,7 @@
       </p:sp>
       <p:sp>
         <p:nvSpPr>
-          <p:cNvPr id="26" name="Text 24"/>
+          <p:cNvPr id="33" name="Text 30"/>
           <p:cNvSpPr/>
           <p:nvPr/>
         </p:nvSpPr>
@@ -5872,7 +6098,7 @@
                 <a:ea typeface="Calibri" pitchFamily="34" charset="-122"/>
                 <a:cs typeface="Calibri" pitchFamily="34" charset="-120"/>
               </a:rPr>
-              <a:t>Tabla de Transiciones δ</a:t>
+              <a:t>Tabla de Transiciones</a:t>
             </a:r>
             <a:endParaRPr lang="en-US" sz="2600" dirty="0"/>
           </a:p>
@@ -5911,7 +6137,7 @@
                 <a:ea typeface="Calibri" pitchFamily="34" charset="-122"/>
                 <a:cs typeface="Calibri" pitchFamily="34" charset="-120"/>
               </a:rPr>
-              <a:t>13 reglas totales — 5 del Atacante, 4 de retirada, 4 de parada_fallida</a:t>
+              <a:t>13 reglas que describen todos los movimientos posibles</a:t>
             </a:r>
             <a:endParaRPr lang="en-US" sz="1250" dirty="0"/>
           </a:p>
@@ -6012,7 +6238,7 @@
                 <a:ea typeface="Calibri" pitchFamily="34" charset="-122"/>
                 <a:cs typeface="Calibri" pitchFamily="34" charset="-120"/>
               </a:rPr>
-              <a:t>Reglas #1–4  (avance + PUSH):  avance, G/L·G  |  avance, L/M·L  |  avance, M/C·M  |  avance, C/CC·C</a:t>
+              <a:t>Hay cinco reglas para el atacante: cuatro de avance y una de tocado que lleva a la victoria</a:t>
             </a:r>
             <a:endParaRPr lang="en-US" sz="1450" dirty="0"/>
           </a:p>
@@ -6113,7 +6339,7 @@
                 <a:ea typeface="Calibri" pitchFamily="34" charset="-122"/>
                 <a:cs typeface="Calibri" pitchFamily="34" charset="-120"/>
               </a:rPr>
-              <a:t>Regla #5  (VICTORIA):  tocado, CC / CC  →  q_v  ★  — único punto de aceptación</a:t>
+              <a:t>El tocado solo es válido cuando el atacante está en corps-à-corps, la posición más cercana</a:t>
             </a:r>
             <a:endParaRPr lang="en-US" sz="1450" dirty="0"/>
           </a:p>
@@ -6214,7 +6440,7 @@
                 <a:ea typeface="Calibri" pitchFamily="34" charset="-122"/>
                 <a:cs typeface="Calibri" pitchFamily="34" charset="-120"/>
               </a:rPr>
-              <a:t>Reglas #6–9  (retirada + POP):  retirada, X / ε  con X ∈ {L, M, C, CC}  →  vuelve a q_a</a:t>
+              <a:t>Hay cuatro reglas de retirada: el defensor retrocede desde cualquier posición, excepto desde la guardia inicial</a:t>
             </a:r>
             <a:endParaRPr lang="en-US" sz="1450" dirty="0"/>
           </a:p>
@@ -6315,7 +6541,7 @@
                 <a:ea typeface="Calibri" pitchFamily="34" charset="-122"/>
                 <a:cs typeface="Calibri" pitchFamily="34" charset="-120"/>
               </a:rPr>
-              <a:t>Reglas #10–13  (parada_fallida + NO-OP):  parada_fallida, X / X  con X ∈ {L, M, C, CC}</a:t>
+              <a:t>Hay cuatro reglas de parada fallida: no cambia nada, solo pasa el turno al atacante</a:t>
             </a:r>
             <a:endParaRPr lang="en-US" sz="1450" dirty="0"/>
           </a:p>
@@ -6416,7 +6642,7 @@
                 <a:ea typeface="Calibri" pitchFamily="34" charset="-122"/>
                 <a:cs typeface="Calibri" pitchFamily="34" charset="-120"/>
               </a:rPr>
-              <a:t>Sin transición definida = rechazo inmediato  →  ej: tocado con tope G no existe en δ</a:t>
+              <a:t>Si se intenta una acción que no tiene regla definida, el autómata rechaza la cadena inmediatamente</a:t>
             </a:r>
             <a:endParaRPr lang="en-US" sz="1450" dirty="0"/>
           </a:p>
@@ -6704,7 +6930,7 @@
                 <a:ea typeface="Calibri" pitchFamily="34" charset="-122"/>
                 <a:cs typeface="Calibri" pitchFamily="34" charset="-120"/>
               </a:rPr>
-              <a:t>Traza Aceptada ✓</a:t>
+              <a:t>Traza Aceptada</a:t>
             </a:r>
             <a:endParaRPr lang="en-US" sz="2600" dirty="0"/>
           </a:p>
@@ -6743,7 +6969,7 @@
                 <a:ea typeface="Calibri" pitchFamily="34" charset="-122"/>
                 <a:cs typeface="Calibri" pitchFamily="34" charset="-120"/>
               </a:rPr>
-              <a:t>avance · parada_fallida · avance · retirada · avance · avance · parada_fallida · tocado</a:t>
+              <a:t>Secuencia que el autómata acepta — el atacante llega a victoria</a:t>
             </a:r>
             <a:endParaRPr lang="en-US" sz="1250" dirty="0"/>
           </a:p>
@@ -6844,7 +7070,7 @@
                 <a:ea typeface="Calibri" pitchFamily="34" charset="-122"/>
                 <a:cs typeface="Calibri" pitchFamily="34" charset="-120"/>
               </a:rPr>
-              <a:t>Paso 1: avance, G → PUSH L  |  pila: L G  |  pasa a q_d  (A avanzó a largo)</a:t>
+              <a:t>El atacante avanza hasta largo — el defensor falla la parada y no logra nada</a:t>
             </a:r>
             <a:endParaRPr lang="en-US" sz="1450" dirty="0"/>
           </a:p>
@@ -6945,7 +7171,7 @@
                 <a:ea typeface="Calibri" pitchFamily="34" charset="-122"/>
                 <a:cs typeface="Calibri" pitchFamily="34" charset="-120"/>
               </a:rPr>
-              <a:t>Paso 2: parada_fallida, L → NO-OP  |  pila: L G  |  vuelve a q_a  (O falló la parada)</a:t>
+              <a:t>El atacante avanza a medio — el defensor logra retroceder y lo empuja de vuelta a largo</a:t>
             </a:r>
             <a:endParaRPr lang="en-US" sz="1450" dirty="0"/>
           </a:p>
@@ -7046,7 +7272,7 @@
                 <a:ea typeface="Calibri" pitchFamily="34" charset="-122"/>
                 <a:cs typeface="Calibri" pitchFamily="34" charset="-120"/>
               </a:rPr>
-              <a:t>Paso 3–4: avance M (PUSH) → retirada M (POP)  |  O logró retroceder a largo</a:t>
+              <a:t>El atacante re-avanza a medio, luego a corto, luego a corps-à-corps — la pila acumula todo el recorrido</a:t>
             </a:r>
             <a:endParaRPr lang="en-US" sz="1450" dirty="0"/>
           </a:p>
@@ -7147,7 +7373,7 @@
                 <a:ea typeface="Calibri" pitchFamily="34" charset="-122"/>
                 <a:cs typeface="Calibri" pitchFamily="34" charset="-120"/>
               </a:rPr>
-              <a:t>Pasos 5–9: A re-avanza hasta CC  |  pila crece: M L G → C M L G → CC C M L G</a:t>
+              <a:t>El defensor vuelve a fallar la parada — no puede detener el remate</a:t>
             </a:r>
             <a:endParaRPr lang="en-US" sz="1450" dirty="0"/>
           </a:p>
@@ -7248,7 +7474,7 @@
                 <a:ea typeface="Calibri" pitchFamily="34" charset="-122"/>
                 <a:cs typeface="Calibri" pitchFamily="34" charset="-120"/>
               </a:rPr>
-              <a:t>Paso 10: tocado, CC → q_v  ★  |  cadena ACEPTADA  |  la pila conservó todo el historial</a:t>
+              <a:t>El atacante ejecuta el tocado desde corps-à-corps — el autómata acepta, la cadena pertenece al lenguaje</a:t>
             </a:r>
             <a:endParaRPr lang="en-US" sz="1450" dirty="0"/>
           </a:p>
@@ -7536,7 +7762,7 @@
                 <a:ea typeface="Calibri" pitchFamily="34" charset="-122"/>
                 <a:cs typeface="Calibri" pitchFamily="34" charset="-120"/>
               </a:rPr>
-              <a:t>Traza Rechazada ✗</a:t>
+              <a:t>Traza Rechazada</a:t>
             </a:r>
             <a:endParaRPr lang="en-US" sz="2600" dirty="0"/>
           </a:p>
@@ -7575,7 +7801,7 @@
                 <a:ea typeface="Calibri" pitchFamily="34" charset="-122"/>
                 <a:cs typeface="Calibri" pitchFamily="34" charset="-120"/>
               </a:rPr>
-              <a:t>avance · retirada · tocado</a:t>
+              <a:t>Secuencia que el autómata rechaza — el atacante no puede rematar</a:t>
             </a:r>
             <a:endParaRPr lang="en-US" sz="1250" dirty="0"/>
           </a:p>
@@ -7676,7 +7902,7 @@
                 <a:ea typeface="Calibri" pitchFamily="34" charset="-122"/>
                 <a:cs typeface="Calibri" pitchFamily="34" charset="-120"/>
               </a:rPr>
-              <a:t>Paso 1: avance, G → PUSH L  |  pila: L G  |  pasa a q_d</a:t>
+              <a:t>El atacante avanza hasta largo — primer movimiento válido</a:t>
             </a:r>
             <a:endParaRPr lang="en-US" sz="1450" dirty="0"/>
           </a:p>
@@ -7777,7 +8003,7 @@
                 <a:ea typeface="Calibri" pitchFamily="34" charset="-122"/>
                 <a:cs typeface="Calibri" pitchFamily="34" charset="-120"/>
               </a:rPr>
-              <a:t>Paso 2: retirada, L → POP  |  pila: G  |  vuelve a q_a  (O retrocedió hasta En Garde)</a:t>
+              <a:t>El defensor logra retroceder — empuja al atacante de vuelta a la posición de guardia inicial</a:t>
             </a:r>
             <a:endParaRPr lang="en-US" sz="1450" dirty="0"/>
           </a:p>
@@ -7878,7 +8104,7 @@
                 <a:ea typeface="Calibri" pitchFamily="34" charset="-122"/>
                 <a:cs typeface="Calibri" pitchFamily="34" charset="-120"/>
               </a:rPr>
-              <a:t>Paso 3: tocado con tope G  →  δ(q_a, tocado, G) NO ESTÁ DEFINIDA  →  RECHAZA</a:t>
+              <a:t>El atacante intenta hacer el tocado estando en la guardia inicial — esa acción no existe en la tabla</a:t>
             </a:r>
             <a:endParaRPr lang="en-US" sz="1450" dirty="0"/>
           </a:p>
@@ -7979,7 +8205,7 @@
                 <a:ea typeface="Calibri" pitchFamily="34" charset="-122"/>
                 <a:cs typeface="Calibri" pitchFamily="34" charset="-120"/>
               </a:rPr>
-              <a:t>Razón formal: "tocado" solo es válido cuando el tope es CC (corps-à-corps)</a:t>
+              <a:t>El autómata rechaza inmediatamente: no hay transición definida para esa situación</a:t>
             </a:r>
             <a:endParaRPr lang="en-US" sz="1450" dirty="0"/>
           </a:p>
@@ -8080,7 +8306,7 @@
                 <a:ea typeface="Calibri" pitchFamily="34" charset="-122"/>
                 <a:cs typeface="Calibri" pitchFamily="34" charset="-120"/>
               </a:rPr>
-              <a:t>A perdió toda ventaja de posición antes de poder rematar  →  cadena no pertenece al lenguaje</a:t>
+              <a:t>Razón: el tocado solo es válido desde corps-à-corps — intentarlo desde la guardia es inválido</a:t>
             </a:r>
             <a:endParaRPr lang="en-US" sz="1450" dirty="0"/>
           </a:p>
@@ -8407,7 +8633,7 @@
                 <a:ea typeface="Calibri" pitchFamily="34" charset="-122"/>
                 <a:cs typeface="Calibri" pitchFamily="34" charset="-120"/>
               </a:rPr>
-              <a:t>Entrevista grupal · 10 minutos · Todos los integrantes deben poder responder</a:t>
+              <a:t>Entrevista grupal · 10 minutos · Todos deben poder responder</a:t>
             </a:r>
             <a:endParaRPr lang="en-US" sz="1250" dirty="0"/>
           </a:p>
@@ -8508,7 +8734,7 @@
                 <a:ea typeface="Calibri" pitchFamily="34" charset="-122"/>
                 <a:cs typeface="Calibri" pitchFamily="34" charset="-120"/>
               </a:rPr>
-              <a:t>15 pts  →  Contexto del dominio: roles, posiciones, condición de victoria</a:t>
+              <a:t>15 puntos — explicar el dominio: los roles, las posiciones y la condición de victoria</a:t>
             </a:r>
             <a:endParaRPr lang="en-US" sz="1450" dirty="0"/>
           </a:p>
@@ -8609,7 +8835,7 @@
                 <a:ea typeface="Calibri" pitchFamily="34" charset="-122"/>
                 <a:cs typeface="Calibri" pitchFamily="34" charset="-120"/>
               </a:rPr>
-              <a:t>25 pts  →  Definición formal completa: Q, Σ, Γ, δ, q₀, Z₀, F + diagrama + tabla</a:t>
+              <a:t>25 puntos — definición formal completa: los siete componentes, el diagrama y la tabla</a:t>
             </a:r>
             <a:endParaRPr lang="en-US" sz="1450" dirty="0"/>
           </a:p>
@@ -8710,7 +8936,7 @@
                 <a:ea typeface="Calibri" pitchFamily="34" charset="-122"/>
                 <a:cs typeface="Calibri" pitchFamily="34" charset="-120"/>
               </a:rPr>
-              <a:t>20 pts  →  Justificación de diseño: semántica de la pila, PDA vs AFD</a:t>
+              <a:t>20 puntos — justificar las decisiones: por qué la pila, por qué PDA y no AFD</a:t>
             </a:r>
             <a:endParaRPr lang="en-US" sz="1450" dirty="0"/>
           </a:p>
@@ -8811,7 +9037,7 @@
                 <a:ea typeface="Calibri" pitchFamily="34" charset="-122"/>
                 <a:cs typeface="Calibri" pitchFamily="34" charset="-120"/>
               </a:rPr>
-              <a:t>12 + 12 pts  →  Traza aceptada y traza rechazada explicadas paso a paso</a:t>
+              <a:t>12 + 12 puntos — trazar paso a paso la cadena aceptada y explicar la rechazada</a:t>
             </a:r>
             <a:endParaRPr lang="en-US" sz="1450" dirty="0"/>
           </a:p>
@@ -8912,7 +9138,7 @@
                 <a:ea typeface="Calibri" pitchFamily="34" charset="-122"/>
                 <a:cs typeface="Calibri" pitchFamily="34" charset="-120"/>
               </a:rPr>
-              <a:t>10 + 6 pts  →  Justificación del dominio + dominio del tema ante preguntas del profe</a:t>
+              <a:t>10 + 6 puntos — justificar el dominio y responder las preguntas del profesor con solvencia</a:t>
             </a:r>
             <a:endParaRPr lang="en-US" sz="1450" dirty="0"/>
           </a:p>

</xml_diff>

<commit_message>
fix: actualizar ramo a Lenguaje y Autómatas y añadir integrantes
</commit_message>
<xml_diff>
--- a/Proyecto_PDA_Esgrima.pptx
+++ b/Proyecto_PDA_Esgrima.pptx
@@ -1673,7 +1673,7 @@
                 <a:ea typeface="Calibri" pitchFamily="34" charset="-122"/>
                 <a:cs typeface="Calibri" pitchFamily="34" charset="-120"/>
               </a:rPr>
-              <a:t>TEORÍA DE AUTÓMATAS Y LENGUAJES FORMALES  //  TRABAJO GRUPAL</a:t>
+              <a:t>LENGUAJE Y AUTÓMATAS  //  TRABAJO GRUPAL</a:t>
             </a:r>
             <a:endParaRPr lang="en-US" sz="950" dirty="0"/>
           </a:p>
@@ -1789,7 +1789,7 @@
         <p:spPr>
           <a:xfrm>
             <a:off x="365760" y="2487168"/>
-            <a:ext cx="1463040" cy="365760"/>
+            <a:ext cx="1828800" cy="365760"/>
           </a:xfrm>
           <a:prstGeom prst="rect">
             <a:avLst/>
@@ -1813,7 +1813,7 @@
                 <a:ea typeface="Calibri" pitchFamily="34" charset="-122"/>
                 <a:cs typeface="Calibri" pitchFamily="34" charset="-120"/>
               </a:rPr>
-              <a:t>Dominio:</a:t>
+              <a:t>Integrantes:</a:t>
             </a:r>
             <a:endParaRPr lang="en-US" sz="1150" dirty="0"/>
           </a:p>
@@ -1827,8 +1827,8 @@
         </p:nvSpPr>
         <p:spPr>
           <a:xfrm>
-            <a:off x="1920240" y="2487168"/>
-            <a:ext cx="9875520" cy="365760"/>
+            <a:off x="2286000" y="2487168"/>
+            <a:ext cx="9509760" cy="365760"/>
           </a:xfrm>
           <a:prstGeom prst="rect">
             <a:avLst/>
@@ -1852,7 +1852,7 @@
                 <a:ea typeface="Calibri" pitchFamily="34" charset="-122"/>
                 <a:cs typeface="Calibri" pitchFamily="34" charset="-120"/>
               </a:rPr>
-              <a:t>Esgrima (Florete)</a:t>
+              <a:t>Benjamin Maldonado, Ricardo Gil, Amalia Toledo</a:t>
             </a:r>
             <a:endParaRPr lang="en-US" sz="1250" dirty="0"/>
           </a:p>
@@ -1889,8 +1889,8 @@
         </p:nvSpPr>
         <p:spPr>
           <a:xfrm>
-            <a:off x="365760" y="3108960"/>
-            <a:ext cx="1463040" cy="365760"/>
+            <a:off x="365760" y="3081528"/>
+            <a:ext cx="1828800" cy="365760"/>
           </a:xfrm>
           <a:prstGeom prst="rect">
             <a:avLst/>
@@ -1914,7 +1914,7 @@
                 <a:ea typeface="Calibri" pitchFamily="34" charset="-122"/>
                 <a:cs typeface="Calibri" pitchFamily="34" charset="-120"/>
               </a:rPr>
-              <a:t>Modelo:</a:t>
+              <a:t>Dominio:</a:t>
             </a:r>
             <a:endParaRPr lang="en-US" sz="1150" dirty="0"/>
           </a:p>
@@ -1928,8 +1928,8 @@
         </p:nvSpPr>
         <p:spPr>
           <a:xfrm>
-            <a:off x="1920240" y="3108960"/>
-            <a:ext cx="9875520" cy="365760"/>
+            <a:off x="2286000" y="3081528"/>
+            <a:ext cx="9509760" cy="365760"/>
           </a:xfrm>
           <a:prstGeom prst="rect">
             <a:avLst/>
@@ -1953,7 +1953,7 @@
                 <a:ea typeface="Calibri" pitchFamily="34" charset="-122"/>
                 <a:cs typeface="Calibri" pitchFamily="34" charset="-120"/>
               </a:rPr>
-              <a:t>Autómata Apilador — PDA</a:t>
+              <a:t>Esgrima (Florete)</a:t>
             </a:r>
             <a:endParaRPr lang="en-US" sz="1250" dirty="0"/>
           </a:p>
@@ -1967,7 +1967,7 @@
         </p:nvSpPr>
         <p:spPr>
           <a:xfrm>
-            <a:off x="365760" y="3493008"/>
+            <a:off x="365760" y="3465576"/>
             <a:ext cx="11430000" cy="0"/>
           </a:xfrm>
           <a:prstGeom prst="line">
@@ -1990,8 +1990,8 @@
         </p:nvSpPr>
         <p:spPr>
           <a:xfrm>
-            <a:off x="365760" y="3730752"/>
-            <a:ext cx="1463040" cy="365760"/>
+            <a:off x="365760" y="3675888"/>
+            <a:ext cx="1828800" cy="365760"/>
           </a:xfrm>
           <a:prstGeom prst="rect">
             <a:avLst/>
@@ -2015,7 +2015,7 @@
                 <a:ea typeface="Calibri" pitchFamily="34" charset="-122"/>
                 <a:cs typeface="Calibri" pitchFamily="34" charset="-120"/>
               </a:rPr>
-              <a:t>Estados:</a:t>
+              <a:t>Modelo:</a:t>
             </a:r>
             <a:endParaRPr lang="en-US" sz="1150" dirty="0"/>
           </a:p>
@@ -2029,8 +2029,8 @@
         </p:nvSpPr>
         <p:spPr>
           <a:xfrm>
-            <a:off x="1920240" y="3730752"/>
-            <a:ext cx="9875520" cy="365760"/>
+            <a:off x="2286000" y="3675888"/>
+            <a:ext cx="9509760" cy="365760"/>
           </a:xfrm>
           <a:prstGeom prst="rect">
             <a:avLst/>
@@ -2054,7 +2054,7 @@
                 <a:ea typeface="Calibri" pitchFamily="34" charset="-122"/>
                 <a:cs typeface="Calibri" pitchFamily="34" charset="-120"/>
               </a:rPr>
-              <a:t>Ataque  /  Defensa  /  Victoria</a:t>
+              <a:t>Autómata Apilador — PDA</a:t>
             </a:r>
             <a:endParaRPr lang="en-US" sz="1250" dirty="0"/>
           </a:p>
@@ -2068,7 +2068,7 @@
         </p:nvSpPr>
         <p:spPr>
           <a:xfrm>
-            <a:off x="365760" y="4114800"/>
+            <a:off x="365760" y="4059936"/>
             <a:ext cx="11430000" cy="0"/>
           </a:xfrm>
           <a:prstGeom prst="line">
@@ -2091,8 +2091,8 @@
         </p:nvSpPr>
         <p:spPr>
           <a:xfrm>
-            <a:off x="365760" y="4352544"/>
-            <a:ext cx="1463040" cy="365760"/>
+            <a:off x="365760" y="4270248"/>
+            <a:ext cx="1828800" cy="365760"/>
           </a:xfrm>
           <a:prstGeom prst="rect">
             <a:avLst/>
@@ -2116,7 +2116,7 @@
                 <a:ea typeface="Calibri" pitchFamily="34" charset="-122"/>
                 <a:cs typeface="Calibri" pitchFamily="34" charset="-120"/>
               </a:rPr>
-              <a:t>Pila:</a:t>
+              <a:t>Estados:</a:t>
             </a:r>
             <a:endParaRPr lang="en-US" sz="1150" dirty="0"/>
           </a:p>
@@ -2130,8 +2130,8 @@
         </p:nvSpPr>
         <p:spPr>
           <a:xfrm>
-            <a:off x="1920240" y="4352544"/>
-            <a:ext cx="9875520" cy="365760"/>
+            <a:off x="2286000" y="4270248"/>
+            <a:ext cx="9509760" cy="365760"/>
           </a:xfrm>
           <a:prstGeom prst="rect">
             <a:avLst/>
@@ -2155,7 +2155,7 @@
                 <a:ea typeface="Calibri" pitchFamily="34" charset="-122"/>
                 <a:cs typeface="Calibri" pitchFamily="34" charset="-120"/>
               </a:rPr>
-              <a:t>5 posiciones de combate</a:t>
+              <a:t>Ataque  /  Defensa  /  Victoria</a:t>
             </a:r>
             <a:endParaRPr lang="en-US" sz="1250" dirty="0"/>
           </a:p>
@@ -2169,7 +2169,7 @@
         </p:nvSpPr>
         <p:spPr>
           <a:xfrm>
-            <a:off x="365760" y="4736592"/>
+            <a:off x="365760" y="4654296"/>
             <a:ext cx="11430000" cy="0"/>
           </a:xfrm>
           <a:prstGeom prst="line">
@@ -2192,8 +2192,8 @@
         </p:nvSpPr>
         <p:spPr>
           <a:xfrm>
-            <a:off x="365760" y="4974336"/>
-            <a:ext cx="1463040" cy="365760"/>
+            <a:off x="365760" y="4864608"/>
+            <a:ext cx="1828800" cy="365760"/>
           </a:xfrm>
           <a:prstGeom prst="rect">
             <a:avLst/>
@@ -2217,6 +2217,107 @@
                 <a:ea typeface="Calibri" pitchFamily="34" charset="-122"/>
                 <a:cs typeface="Calibri" pitchFamily="34" charset="-120"/>
               </a:rPr>
+              <a:t>Pila:</a:t>
+            </a:r>
+            <a:endParaRPr lang="en-US" sz="1150" dirty="0"/>
+          </a:p>
+        </p:txBody>
+      </p:sp>
+      <p:sp>
+        <p:nvSpPr>
+          <p:cNvPr id="22" name="Text 20"/>
+          <p:cNvSpPr/>
+          <p:nvPr/>
+        </p:nvSpPr>
+        <p:spPr>
+          <a:xfrm>
+            <a:off x="2286000" y="4864608"/>
+            <a:ext cx="9509760" cy="365760"/>
+          </a:xfrm>
+          <a:prstGeom prst="rect">
+            <a:avLst/>
+          </a:prstGeom>
+          <a:noFill/>
+          <a:ln/>
+        </p:spPr>
+        <p:txBody>
+          <a:bodyPr wrap="square" rtlCol="0" anchor="ctr"/>
+          <a:lstStyle/>
+          <a:p>
+            <a:pPr indent="0" marL="0">
+              <a:buNone/>
+            </a:pPr>
+            <a:r>
+              <a:rPr lang="en-US" sz="1250" dirty="0">
+                <a:solidFill>
+                  <a:srgbClr val="E0E0E0"/>
+                </a:solidFill>
+                <a:latin typeface="Calibri" pitchFamily="34" charset="0"/>
+                <a:ea typeface="Calibri" pitchFamily="34" charset="-122"/>
+                <a:cs typeface="Calibri" pitchFamily="34" charset="-120"/>
+              </a:rPr>
+              <a:t>5 posiciones de combate</a:t>
+            </a:r>
+            <a:endParaRPr lang="en-US" sz="1250" dirty="0"/>
+          </a:p>
+        </p:txBody>
+      </p:sp>
+      <p:sp>
+        <p:nvSpPr>
+          <p:cNvPr id="23" name="Shape 21"/>
+          <p:cNvSpPr/>
+          <p:nvPr/>
+        </p:nvSpPr>
+        <p:spPr>
+          <a:xfrm>
+            <a:off x="365760" y="5248656"/>
+            <a:ext cx="11430000" cy="0"/>
+          </a:xfrm>
+          <a:prstGeom prst="line">
+            <a:avLst/>
+          </a:prstGeom>
+          <a:noFill/>
+          <a:ln w="5080">
+            <a:solidFill>
+              <a:srgbClr val="0F3460"/>
+            </a:solidFill>
+            <a:prstDash val="solid"/>
+          </a:ln>
+        </p:spPr>
+      </p:sp>
+      <p:sp>
+        <p:nvSpPr>
+          <p:cNvPr id="24" name="Text 22"/>
+          <p:cNvSpPr/>
+          <p:nvPr/>
+        </p:nvSpPr>
+        <p:spPr>
+          <a:xfrm>
+            <a:off x="365760" y="5458968"/>
+            <a:ext cx="1828800" cy="365760"/>
+          </a:xfrm>
+          <a:prstGeom prst="rect">
+            <a:avLst/>
+          </a:prstGeom>
+          <a:noFill/>
+          <a:ln/>
+        </p:spPr>
+        <p:txBody>
+          <a:bodyPr wrap="square" rtlCol="0" anchor="ctr"/>
+          <a:lstStyle/>
+          <a:p>
+            <a:pPr indent="0" marL="0">
+              <a:buNone/>
+            </a:pPr>
+            <a:r>
+              <a:rPr lang="en-US" sz="1150" b="1" dirty="0">
+                <a:solidFill>
+                  <a:srgbClr val="F5A623"/>
+                </a:solidFill>
+                <a:latin typeface="Calibri" pitchFamily="34" charset="0"/>
+                <a:ea typeface="Calibri" pitchFamily="34" charset="-122"/>
+                <a:cs typeface="Calibri" pitchFamily="34" charset="-120"/>
+              </a:rPr>
               <a:t>Reglas:</a:t>
             </a:r>
             <a:endParaRPr lang="en-US" sz="1150" dirty="0"/>
@@ -2225,14 +2326,14 @@
       </p:sp>
       <p:sp>
         <p:nvSpPr>
-          <p:cNvPr id="22" name="Text 20"/>
-          <p:cNvSpPr/>
-          <p:nvPr/>
-        </p:nvSpPr>
-        <p:spPr>
-          <a:xfrm>
-            <a:off x="1920240" y="4974336"/>
-            <a:ext cx="9875520" cy="365760"/>
+          <p:cNvPr id="25" name="Text 23"/>
+          <p:cNvSpPr/>
+          <p:nvPr/>
+        </p:nvSpPr>
+        <p:spPr>
+          <a:xfrm>
+            <a:off x="2286000" y="5458968"/>
+            <a:ext cx="9509760" cy="365760"/>
           </a:xfrm>
           <a:prstGeom prst="rect">
             <a:avLst/>
@@ -2264,7 +2365,7 @@
       </p:sp>
       <p:sp>
         <p:nvSpPr>
-          <p:cNvPr id="23" name="Shape 21"/>
+          <p:cNvPr id="26" name="Shape 24"/>
           <p:cNvSpPr/>
           <p:nvPr/>
         </p:nvSpPr>
@@ -2284,7 +2385,7 @@
       </p:sp>
       <p:sp>
         <p:nvSpPr>
-          <p:cNvPr id="24" name="Text 22"/>
+          <p:cNvPr id="27" name="Text 25"/>
           <p:cNvSpPr/>
           <p:nvPr/>
         </p:nvSpPr>
@@ -2505,7 +2606,7 @@
                 <a:ea typeface="Calibri" pitchFamily="34" charset="-122"/>
                 <a:cs typeface="Calibri" pitchFamily="34" charset="-120"/>
               </a:rPr>
-              <a:t>TEORÍA DE AUTÓMATAS  //  TRABAJO GRUPAL</a:t>
+              <a:t>LENGUAJE Y AUTÓMATAS  //  TRABAJO GRUPAL</a:t>
             </a:r>
             <a:endParaRPr lang="en-US" sz="850" dirty="0"/>
           </a:p>
@@ -3337,7 +3438,7 @@
                 <a:ea typeface="Calibri" pitchFamily="34" charset="-122"/>
                 <a:cs typeface="Calibri" pitchFamily="34" charset="-120"/>
               </a:rPr>
-              <a:t>TEORÍA DE AUTÓMATAS  //  TRABAJO GRUPAL</a:t>
+              <a:t>LENGUAJE Y AUTÓMATAS  //  TRABAJO GRUPAL</a:t>
             </a:r>
             <a:endParaRPr lang="en-US" sz="850" dirty="0"/>
           </a:p>
@@ -4169,7 +4270,7 @@
                 <a:ea typeface="Calibri" pitchFamily="34" charset="-122"/>
                 <a:cs typeface="Calibri" pitchFamily="34" charset="-120"/>
               </a:rPr>
-              <a:t>TEORÍA DE AUTÓMATAS  //  TRABAJO GRUPAL</a:t>
+              <a:t>LENGUAJE Y AUTÓMATAS  //  TRABAJO GRUPAL</a:t>
             </a:r>
             <a:endParaRPr lang="en-US" sz="850" dirty="0"/>
           </a:p>
@@ -5001,7 +5102,7 @@
                 <a:ea typeface="Calibri" pitchFamily="34" charset="-122"/>
                 <a:cs typeface="Calibri" pitchFamily="34" charset="-120"/>
               </a:rPr>
-              <a:t>TEORÍA DE AUTÓMATAS  //  TRABAJO GRUPAL</a:t>
+              <a:t>LENGUAJE Y AUTÓMATAS  //  TRABAJO GRUPAL</a:t>
             </a:r>
             <a:endParaRPr lang="en-US" sz="850" dirty="0"/>
           </a:p>
@@ -6059,7 +6160,7 @@
                 <a:ea typeface="Calibri" pitchFamily="34" charset="-122"/>
                 <a:cs typeface="Calibri" pitchFamily="34" charset="-120"/>
               </a:rPr>
-              <a:t>TEORÍA DE AUTÓMATAS  //  TRABAJO GRUPAL</a:t>
+              <a:t>LENGUAJE Y AUTÓMATAS  //  TRABAJO GRUPAL</a:t>
             </a:r>
             <a:endParaRPr lang="en-US" sz="850" dirty="0"/>
           </a:p>
@@ -6891,7 +6992,7 @@
                 <a:ea typeface="Calibri" pitchFamily="34" charset="-122"/>
                 <a:cs typeface="Calibri" pitchFamily="34" charset="-120"/>
               </a:rPr>
-              <a:t>TEORÍA DE AUTÓMATAS  //  TRABAJO GRUPAL</a:t>
+              <a:t>LENGUAJE Y AUTÓMATAS  //  TRABAJO GRUPAL</a:t>
             </a:r>
             <a:endParaRPr lang="en-US" sz="850" dirty="0"/>
           </a:p>
@@ -7723,7 +7824,7 @@
                 <a:ea typeface="Calibri" pitchFamily="34" charset="-122"/>
                 <a:cs typeface="Calibri" pitchFamily="34" charset="-120"/>
               </a:rPr>
-              <a:t>TEORÍA DE AUTÓMATAS  //  TRABAJO GRUPAL</a:t>
+              <a:t>LENGUAJE Y AUTÓMATAS  //  TRABAJO GRUPAL</a:t>
             </a:r>
             <a:endParaRPr lang="en-US" sz="850" dirty="0"/>
           </a:p>
@@ -8555,7 +8656,7 @@
                 <a:ea typeface="Calibri" pitchFamily="34" charset="-122"/>
                 <a:cs typeface="Calibri" pitchFamily="34" charset="-120"/>
               </a:rPr>
-              <a:t>TEORÍA DE AUTÓMATAS  //  TRABAJO GRUPAL</a:t>
+              <a:t>LENGUAJE Y AUTÓMATAS  //  TRABAJO GRUPAL</a:t>
             </a:r>
             <a:endParaRPr lang="en-US" sz="850" dirty="0"/>
           </a:p>

</xml_diff>

<commit_message>
docs: eliminar slide 9 y asignar hablantes en el guion
</commit_message>
<xml_diff>
--- a/Proyecto_PDA_Esgrima.pptx
+++ b/Proyecto_PDA_Esgrima.pptx
@@ -13,10 +13,9 @@
     <p:sldId id="261" r:id="rId7"/>
     <p:sldId id="262" r:id="rId8"/>
     <p:sldId id="263" r:id="rId9"/>
-    <p:sldId id="264" r:id="rId10"/>
   </p:sldIdLst>
   <p:notesMasterIdLst>
-    <p:notesMasterId r:id="rId11"/>
+    <p:notesMasterId r:id="rId10"/>
   </p:notesMasterIdLst>
   <p:sldSz cx="12192000" cy="6858000"/>
   <p:notesSz cx="6858000" cy="12192000"/>
@@ -1168,94 +1167,6 @@
 </p:notes>
 </file>
 
-<file path=ppt/notesSlides/notesSlide9.xml><?xml version="1.0" encoding="utf-8"?>
-<p:notes xmlns:a="http://schemas.openxmlformats.org/drawingml/2006/main" xmlns:r="http://schemas.openxmlformats.org/officeDocument/2006/relationships" xmlns:p="http://schemas.openxmlformats.org/presentationml/2006/main">
-  <p:cSld>
-    <p:spTree>
-      <p:nvGrpSpPr>
-        <p:cNvPr id="1" name=""/>
-        <p:cNvGrpSpPr/>
-        <p:nvPr/>
-      </p:nvGrpSpPr>
-      <p:grpSpPr>
-        <a:xfrm>
-          <a:off x="0" y="0"/>
-          <a:ext cx="0" cy="0"/>
-          <a:chOff x="0" y="0"/>
-          <a:chExt cx="0" cy="0"/>
-        </a:xfrm>
-      </p:grpSpPr>
-      <p:sp>
-        <p:nvSpPr>
-          <p:cNvPr id="2" name="Slide Image Placeholder 1"/>
-          <p:cNvSpPr>
-            <a:spLocks noGrp="1" noRot="1" noChangeAspect="1"/>
-          </p:cNvSpPr>
-          <p:nvPr>
-            <p:ph type="sldImg"/>
-          </p:nvPr>
-        </p:nvSpPr>
-        <p:spPr/>
-      </p:sp>
-      <p:sp>
-        <p:nvSpPr>
-          <p:cNvPr id="3" name="Notes Placeholder 2"/>
-          <p:cNvSpPr>
-            <a:spLocks noGrp="1"/>
-          </p:cNvSpPr>
-          <p:nvPr>
-            <p:ph type="body" idx="1"/>
-          </p:nvPr>
-        </p:nvSpPr>
-        <p:spPr/>
-        <p:txBody>
-          <a:bodyPr/>
-          <a:lstStyle/>
-          <a:p>
-            <a:r>
-              <a:rPr lang="en-US" dirty="0"/>
-              <a:t/>
-            </a:r>
-            <a:endParaRPr lang="en-US" dirty="0"/>
-          </a:p>
-        </p:txBody>
-      </p:sp>
-      <p:sp>
-        <p:nvSpPr>
-          <p:cNvPr id="4" name="Slide Number Placeholder 3"/>
-          <p:cNvSpPr>
-            <a:spLocks noGrp="1"/>
-          </p:cNvSpPr>
-          <p:nvPr>
-            <p:ph type="sldNum" sz="quarter" idx="10"/>
-          </p:nvPr>
-        </p:nvSpPr>
-        <p:spPr/>
-        <p:txBody>
-          <a:bodyPr/>
-          <a:lstStyle/>
-          <a:p>
-            <a:fld id="{F7021451-1387-4CA6-816F-3879F97B5CBC}" type="slidenum">
-              <a:rPr lang="en-US"/>
-              <a:t>9</a:t>
-            </a:fld>
-            <a:endParaRPr lang="en-US"/>
-          </a:p>
-        </p:txBody>
-      </p:sp>
-    </p:spTree>
-    <p:extLst>
-      <p:ext uri="{BB962C8B-B14F-4D97-AF65-F5344CB8AC3E}">
-        <p14:creationId xmlns:p14="http://schemas.microsoft.com/office/powerpoint/2010/main" val="1024086991"/>
-      </p:ext>
-    </p:extLst>
-  </p:cSld>
-  <p:clrMapOvr>
-    <a:masterClrMapping/>
-  </p:clrMapOvr>
-</p:notes>
-</file>
-
 <file path=ppt/slideLayouts/slideLayout1.xml><?xml version="1.0" encoding="utf-8"?>
 <p:sldLayout xmlns:a="http://schemas.openxmlformats.org/drawingml/2006/main" xmlns:r="http://schemas.openxmlformats.org/officeDocument/2006/relationships" xmlns:p="http://schemas.openxmlformats.org/presentationml/2006/main" preserve="1">
   <p:cSld name="DEFAULT">
@@ -7405,716 +7316,6 @@
                 <a:cs typeface="Calibri" pitchFamily="34" charset="-120"/>
               </a:rPr>
               <a:t>Razón: el tocado solo es válido desde corps-à-corps — intentarlo desde la guardia es inválido</a:t>
-            </a:r>
-            <a:endParaRPr lang="en-US" sz="1800" dirty="0"/>
-          </a:p>
-        </p:txBody>
-      </p:sp>
-      <p:sp>
-        <p:nvSpPr>
-          <p:cNvPr id="24" name="Shape 22"/>
-          <p:cNvSpPr/>
-          <p:nvPr/>
-        </p:nvSpPr>
-        <p:spPr>
-          <a:xfrm>
-            <a:off x="0" y="6492240"/>
-            <a:ext cx="12188952" cy="365760"/>
-          </a:xfrm>
-          <a:prstGeom prst="rect">
-            <a:avLst/>
-          </a:prstGeom>
-          <a:solidFill>
-            <a:srgbClr val="475B7A"/>
-          </a:solidFill>
-          <a:ln/>
-        </p:spPr>
-      </p:sp>
-      <p:sp>
-        <p:nvSpPr>
-          <p:cNvPr id="25" name="Text 23"/>
-          <p:cNvSpPr/>
-          <p:nvPr/>
-        </p:nvSpPr>
-        <p:spPr>
-          <a:xfrm>
-            <a:off x="457200" y="6492240"/>
-            <a:ext cx="10972800" cy="365760"/>
-          </a:xfrm>
-          <a:prstGeom prst="rect">
-            <a:avLst/>
-          </a:prstGeom>
-          <a:noFill/>
-          <a:ln/>
-        </p:spPr>
-        <p:txBody>
-          <a:bodyPr wrap="square" rtlCol="0" anchor="ctr"/>
-          <a:lstStyle/>
-          <a:p>
-            <a:pPr indent="0" marL="0">
-              <a:buNone/>
-            </a:pPr>
-            <a:r>
-              <a:rPr lang="en-US" sz="1000" dirty="0">
-                <a:solidFill>
-                  <a:srgbClr val="FFFFFF"/>
-                </a:solidFill>
-                <a:latin typeface="Calibri" pitchFamily="34" charset="0"/>
-                <a:ea typeface="Calibri" pitchFamily="34" charset="-122"/>
-                <a:cs typeface="Calibri" pitchFamily="34" charset="-120"/>
-              </a:rPr>
-              <a:t>PDA – Autómata Apilador · Secuencias de Victoria · Esgrima</a:t>
-            </a:r>
-            <a:endParaRPr lang="en-US" sz="1000" dirty="0"/>
-          </a:p>
-        </p:txBody>
-      </p:sp>
-    </p:spTree>
-  </p:cSld>
-  <p:clrMapOvr>
-    <a:masterClrMapping/>
-  </p:clrMapOvr>
-</p:sld>
-</file>
-
-<file path=ppt/slides/slide9.xml><?xml version="1.0" encoding="utf-8"?>
-<p:sld xmlns:a="http://schemas.openxmlformats.org/drawingml/2006/main" xmlns:r="http://schemas.openxmlformats.org/officeDocument/2006/relationships" xmlns:p="http://schemas.openxmlformats.org/presentationml/2006/main">
-  <p:cSld name="Slide 9">
-    <p:spTree>
-      <p:nvGrpSpPr>
-        <p:cNvPr id="1" name=""/>
-        <p:cNvGrpSpPr/>
-        <p:nvPr/>
-      </p:nvGrpSpPr>
-      <p:grpSpPr>
-        <a:xfrm>
-          <a:off x="0" y="0"/>
-          <a:ext cx="0" cy="0"/>
-          <a:chOff x="0" y="0"/>
-          <a:chExt cx="0" cy="0"/>
-        </a:xfrm>
-      </p:grpSpPr>
-      <p:sp>
-        <p:nvSpPr>
-          <p:cNvPr id="2" name="Shape 0"/>
-          <p:cNvSpPr/>
-          <p:nvPr/>
-        </p:nvSpPr>
-        <p:spPr>
-          <a:xfrm>
-            <a:off x="0" y="0"/>
-            <a:ext cx="12188952" cy="6858000"/>
-          </a:xfrm>
-          <a:prstGeom prst="rect">
-            <a:avLst/>
-          </a:prstGeom>
-          <a:solidFill>
-            <a:srgbClr val="FFFFFF"/>
-          </a:solidFill>
-          <a:ln/>
-        </p:spPr>
-      </p:sp>
-      <p:sp>
-        <p:nvSpPr>
-          <p:cNvPr id="3" name="Shape 1"/>
-          <p:cNvSpPr/>
-          <p:nvPr/>
-        </p:nvSpPr>
-        <p:spPr>
-          <a:xfrm>
-            <a:off x="0" y="0"/>
-            <a:ext cx="12188952" cy="91440"/>
-          </a:xfrm>
-          <a:prstGeom prst="rect">
-            <a:avLst/>
-          </a:prstGeom>
-          <a:solidFill>
-            <a:srgbClr val="475B7A"/>
-          </a:solidFill>
-          <a:ln/>
-        </p:spPr>
-      </p:sp>
-      <p:sp>
-        <p:nvSpPr>
-          <p:cNvPr id="4" name="Shape 2"/>
-          <p:cNvSpPr/>
-          <p:nvPr/>
-        </p:nvSpPr>
-        <p:spPr>
-          <a:xfrm>
-            <a:off x="0" y="91440"/>
-            <a:ext cx="12188952" cy="36576"/>
-          </a:xfrm>
-          <a:prstGeom prst="rect">
-            <a:avLst/>
-          </a:prstGeom>
-          <a:solidFill>
-            <a:srgbClr val="C46D54"/>
-          </a:solidFill>
-          <a:ln/>
-        </p:spPr>
-      </p:sp>
-      <p:sp>
-        <p:nvSpPr>
-          <p:cNvPr id="5" name="Text 3"/>
-          <p:cNvSpPr/>
-          <p:nvPr/>
-        </p:nvSpPr>
-        <p:spPr>
-          <a:xfrm>
-            <a:off x="11247120" y="6217920"/>
-            <a:ext cx="731520" cy="457200"/>
-          </a:xfrm>
-          <a:prstGeom prst="rect">
-            <a:avLst/>
-          </a:prstGeom>
-          <a:noFill/>
-          <a:ln/>
-        </p:spPr>
-        <p:txBody>
-          <a:bodyPr wrap="square" rtlCol="0" anchor="ctr"/>
-          <a:lstStyle/>
-          <a:p>
-            <a:pPr algn="r" indent="0" marL="0">
-              <a:buNone/>
-            </a:pPr>
-            <a:r>
-              <a:rPr lang="en-US" sz="1400" b="1" dirty="0">
-                <a:solidFill>
-                  <a:srgbClr val="50B1B6"/>
-                </a:solidFill>
-                <a:latin typeface="Calibri" pitchFamily="34" charset="0"/>
-                <a:ea typeface="Calibri" pitchFamily="34" charset="-122"/>
-                <a:cs typeface="Calibri" pitchFamily="34" charset="-120"/>
-              </a:rPr>
-              <a:t>9</a:t>
-            </a:r>
-            <a:endParaRPr lang="en-US" sz="1400" dirty="0"/>
-          </a:p>
-        </p:txBody>
-      </p:sp>
-      <p:sp>
-        <p:nvSpPr>
-          <p:cNvPr id="6" name="Text 4"/>
-          <p:cNvSpPr/>
-          <p:nvPr/>
-        </p:nvSpPr>
-        <p:spPr>
-          <a:xfrm>
-            <a:off x="457200" y="365760"/>
-            <a:ext cx="9144000" cy="274320"/>
-          </a:xfrm>
-          <a:prstGeom prst="rect">
-            <a:avLst/>
-          </a:prstGeom>
-          <a:noFill/>
-          <a:ln/>
-        </p:spPr>
-        <p:txBody>
-          <a:bodyPr wrap="square" rtlCol="0" anchor="ctr"/>
-          <a:lstStyle/>
-          <a:p>
-            <a:pPr indent="0" marL="0">
-              <a:buNone/>
-            </a:pPr>
-            <a:r>
-              <a:rPr lang="en-US" sz="900" b="1" dirty="0">
-                <a:solidFill>
-                  <a:srgbClr val="888888"/>
-                </a:solidFill>
-                <a:latin typeface="Calibri" pitchFamily="34" charset="0"/>
-                <a:ea typeface="Calibri" pitchFamily="34" charset="-122"/>
-                <a:cs typeface="Calibri" pitchFamily="34" charset="-120"/>
-              </a:rPr>
-              <a:t>LENGUAJE Y AUTÓMATAS  //  TRABAJO GRUPAL</a:t>
-            </a:r>
-            <a:endParaRPr lang="en-US" sz="900" dirty="0"/>
-          </a:p>
-        </p:txBody>
-      </p:sp>
-      <p:sp>
-        <p:nvSpPr>
-          <p:cNvPr id="7" name="Text 5"/>
-          <p:cNvSpPr/>
-          <p:nvPr/>
-        </p:nvSpPr>
-        <p:spPr>
-          <a:xfrm>
-            <a:off x="457200" y="640080"/>
-            <a:ext cx="10607040" cy="594360"/>
-          </a:xfrm>
-          <a:prstGeom prst="rect">
-            <a:avLst/>
-          </a:prstGeom>
-          <a:noFill/>
-          <a:ln/>
-        </p:spPr>
-        <p:txBody>
-          <a:bodyPr wrap="square" rtlCol="0" anchor="ctr"/>
-          <a:lstStyle/>
-          <a:p>
-            <a:pPr indent="0" marL="0">
-              <a:buNone/>
-            </a:pPr>
-            <a:r>
-              <a:rPr lang="en-US" sz="3200" b="1" dirty="0">
-                <a:solidFill>
-                  <a:srgbClr val="475B7A"/>
-                </a:solidFill>
-                <a:latin typeface="Calibri" pitchFamily="34" charset="0"/>
-                <a:ea typeface="Calibri" pitchFamily="34" charset="-122"/>
-                <a:cs typeface="Calibri" pitchFamily="34" charset="-120"/>
-              </a:rPr>
-              <a:t>Criterios de Evaluación</a:t>
-            </a:r>
-            <a:endParaRPr lang="en-US" sz="3200" dirty="0"/>
-          </a:p>
-        </p:txBody>
-      </p:sp>
-      <p:sp>
-        <p:nvSpPr>
-          <p:cNvPr id="8" name="Text 6"/>
-          <p:cNvSpPr/>
-          <p:nvPr/>
-        </p:nvSpPr>
-        <p:spPr>
-          <a:xfrm>
-            <a:off x="457200" y="1234440"/>
-            <a:ext cx="10607040" cy="292608"/>
-          </a:xfrm>
-          <a:prstGeom prst="rect">
-            <a:avLst/>
-          </a:prstGeom>
-          <a:noFill/>
-          <a:ln/>
-        </p:spPr>
-        <p:txBody>
-          <a:bodyPr wrap="square" rtlCol="0" anchor="ctr"/>
-          <a:lstStyle/>
-          <a:p>
-            <a:pPr indent="0" marL="0">
-              <a:buNone/>
-            </a:pPr>
-            <a:r>
-              <a:rPr lang="en-US" sz="1600" i="1" dirty="0">
-                <a:solidFill>
-                  <a:srgbClr val="50B1B6"/>
-                </a:solidFill>
-                <a:latin typeface="Calibri" pitchFamily="34" charset="0"/>
-                <a:ea typeface="Calibri" pitchFamily="34" charset="-122"/>
-                <a:cs typeface="Calibri" pitchFamily="34" charset="-120"/>
-              </a:rPr>
-              <a:t>Entrevista grupal · 10 minutos · Todos deben poder responder</a:t>
-            </a:r>
-            <a:endParaRPr lang="en-US" sz="1600" dirty="0"/>
-          </a:p>
-        </p:txBody>
-      </p:sp>
-      <p:sp>
-        <p:nvSpPr>
-          <p:cNvPr id="9" name="Shape 7"/>
-          <p:cNvSpPr/>
-          <p:nvPr/>
-        </p:nvSpPr>
-        <p:spPr>
-          <a:xfrm>
-            <a:off x="457200" y="1691640"/>
-            <a:ext cx="11274552" cy="0"/>
-          </a:xfrm>
-          <a:prstGeom prst="line">
-            <a:avLst/>
-          </a:prstGeom>
-          <a:noFill/>
-          <a:ln w="19050">
-            <a:solidFill>
-              <a:srgbClr val="C46D54"/>
-            </a:solidFill>
-            <a:prstDash val="solid"/>
-          </a:ln>
-        </p:spPr>
-      </p:sp>
-      <p:sp>
-        <p:nvSpPr>
-          <p:cNvPr id="10" name="Shape 8"/>
-          <p:cNvSpPr/>
-          <p:nvPr/>
-        </p:nvSpPr>
-        <p:spPr>
-          <a:xfrm>
-            <a:off x="502920" y="2103120"/>
-            <a:ext cx="137160" cy="137160"/>
-          </a:xfrm>
-          <a:prstGeom prst="diamond">
-            <a:avLst/>
-          </a:prstGeom>
-          <a:solidFill>
-            <a:srgbClr val="C46D54"/>
-          </a:solidFill>
-          <a:ln/>
-        </p:spPr>
-      </p:sp>
-      <p:sp>
-        <p:nvSpPr>
-          <p:cNvPr id="11" name="Text 9"/>
-          <p:cNvSpPr/>
-          <p:nvPr/>
-        </p:nvSpPr>
-        <p:spPr>
-          <a:xfrm>
-            <a:off x="777240" y="2011680"/>
-            <a:ext cx="10515600" cy="790042"/>
-          </a:xfrm>
-          <a:prstGeom prst="rect">
-            <a:avLst/>
-          </a:prstGeom>
-          <a:noFill/>
-          <a:ln/>
-        </p:spPr>
-        <p:txBody>
-          <a:bodyPr wrap="square" rtlCol="0" anchor="t"/>
-          <a:lstStyle/>
-          <a:p>
-            <a:pPr indent="0" marL="0">
-              <a:buNone/>
-            </a:pPr>
-            <a:r>
-              <a:rPr lang="en-US" sz="1800" dirty="0">
-                <a:solidFill>
-                  <a:srgbClr val="444444"/>
-                </a:solidFill>
-                <a:latin typeface="Calibri" pitchFamily="34" charset="0"/>
-                <a:ea typeface="Calibri" pitchFamily="34" charset="-122"/>
-                <a:cs typeface="Calibri" pitchFamily="34" charset="-120"/>
-              </a:rPr>
-              <a:t>15 puntos — explicar el dominio: los roles, las posiciones y la condición de victoria</a:t>
-            </a:r>
-            <a:endParaRPr lang="en-US" sz="1800" dirty="0"/>
-          </a:p>
-        </p:txBody>
-      </p:sp>
-      <p:sp>
-        <p:nvSpPr>
-          <p:cNvPr id="12" name="Shape 10"/>
-          <p:cNvSpPr/>
-          <p:nvPr/>
-        </p:nvSpPr>
-        <p:spPr>
-          <a:xfrm>
-            <a:off x="777240" y="2845613"/>
-            <a:ext cx="10515600" cy="0"/>
-          </a:xfrm>
-          <a:prstGeom prst="line">
-            <a:avLst/>
-          </a:prstGeom>
-          <a:noFill/>
-          <a:ln w="9525">
-            <a:solidFill>
-              <a:srgbClr val="E0E0E0"/>
-            </a:solidFill>
-            <a:prstDash val="solid"/>
-          </a:ln>
-        </p:spPr>
-      </p:sp>
-      <p:sp>
-        <p:nvSpPr>
-          <p:cNvPr id="13" name="Shape 11"/>
-          <p:cNvSpPr/>
-          <p:nvPr/>
-        </p:nvSpPr>
-        <p:spPr>
-          <a:xfrm>
-            <a:off x="502920" y="2980944"/>
-            <a:ext cx="137160" cy="137160"/>
-          </a:xfrm>
-          <a:prstGeom prst="diamond">
-            <a:avLst/>
-          </a:prstGeom>
-          <a:solidFill>
-            <a:srgbClr val="C46D54"/>
-          </a:solidFill>
-          <a:ln/>
-        </p:spPr>
-      </p:sp>
-      <p:sp>
-        <p:nvSpPr>
-          <p:cNvPr id="14" name="Text 12"/>
-          <p:cNvSpPr/>
-          <p:nvPr/>
-        </p:nvSpPr>
-        <p:spPr>
-          <a:xfrm>
-            <a:off x="777240" y="2889504"/>
-            <a:ext cx="10515600" cy="790042"/>
-          </a:xfrm>
-          <a:prstGeom prst="rect">
-            <a:avLst/>
-          </a:prstGeom>
-          <a:noFill/>
-          <a:ln/>
-        </p:spPr>
-        <p:txBody>
-          <a:bodyPr wrap="square" rtlCol="0" anchor="t"/>
-          <a:lstStyle/>
-          <a:p>
-            <a:pPr indent="0" marL="0">
-              <a:buNone/>
-            </a:pPr>
-            <a:r>
-              <a:rPr lang="en-US" sz="1800" dirty="0">
-                <a:solidFill>
-                  <a:srgbClr val="444444"/>
-                </a:solidFill>
-                <a:latin typeface="Calibri" pitchFamily="34" charset="0"/>
-                <a:ea typeface="Calibri" pitchFamily="34" charset="-122"/>
-                <a:cs typeface="Calibri" pitchFamily="34" charset="-120"/>
-              </a:rPr>
-              <a:t>25 puntos — definición formal completa: los siete componentes, el diagrama y la tabla</a:t>
-            </a:r>
-            <a:endParaRPr lang="en-US" sz="1800" dirty="0"/>
-          </a:p>
-        </p:txBody>
-      </p:sp>
-      <p:sp>
-        <p:nvSpPr>
-          <p:cNvPr id="15" name="Shape 13"/>
-          <p:cNvSpPr/>
-          <p:nvPr/>
-        </p:nvSpPr>
-        <p:spPr>
-          <a:xfrm>
-            <a:off x="777240" y="3723437"/>
-            <a:ext cx="10515600" cy="0"/>
-          </a:xfrm>
-          <a:prstGeom prst="line">
-            <a:avLst/>
-          </a:prstGeom>
-          <a:noFill/>
-          <a:ln w="9525">
-            <a:solidFill>
-              <a:srgbClr val="E0E0E0"/>
-            </a:solidFill>
-            <a:prstDash val="solid"/>
-          </a:ln>
-        </p:spPr>
-      </p:sp>
-      <p:sp>
-        <p:nvSpPr>
-          <p:cNvPr id="16" name="Shape 14"/>
-          <p:cNvSpPr/>
-          <p:nvPr/>
-        </p:nvSpPr>
-        <p:spPr>
-          <a:xfrm>
-            <a:off x="502920" y="3858768"/>
-            <a:ext cx="137160" cy="137160"/>
-          </a:xfrm>
-          <a:prstGeom prst="diamond">
-            <a:avLst/>
-          </a:prstGeom>
-          <a:solidFill>
-            <a:srgbClr val="C46D54"/>
-          </a:solidFill>
-          <a:ln/>
-        </p:spPr>
-      </p:sp>
-      <p:sp>
-        <p:nvSpPr>
-          <p:cNvPr id="17" name="Text 15"/>
-          <p:cNvSpPr/>
-          <p:nvPr/>
-        </p:nvSpPr>
-        <p:spPr>
-          <a:xfrm>
-            <a:off x="777240" y="3767328"/>
-            <a:ext cx="10515600" cy="790042"/>
-          </a:xfrm>
-          <a:prstGeom prst="rect">
-            <a:avLst/>
-          </a:prstGeom>
-          <a:noFill/>
-          <a:ln/>
-        </p:spPr>
-        <p:txBody>
-          <a:bodyPr wrap="square" rtlCol="0" anchor="t"/>
-          <a:lstStyle/>
-          <a:p>
-            <a:pPr indent="0" marL="0">
-              <a:buNone/>
-            </a:pPr>
-            <a:r>
-              <a:rPr lang="en-US" sz="1800" dirty="0">
-                <a:solidFill>
-                  <a:srgbClr val="444444"/>
-                </a:solidFill>
-                <a:latin typeface="Calibri" pitchFamily="34" charset="0"/>
-                <a:ea typeface="Calibri" pitchFamily="34" charset="-122"/>
-                <a:cs typeface="Calibri" pitchFamily="34" charset="-120"/>
-              </a:rPr>
-              <a:t>20 puntos — justificar las decisiones: por qué la pila, por qué PDA y no AFD</a:t>
-            </a:r>
-            <a:endParaRPr lang="en-US" sz="1800" dirty="0"/>
-          </a:p>
-        </p:txBody>
-      </p:sp>
-      <p:sp>
-        <p:nvSpPr>
-          <p:cNvPr id="18" name="Shape 16"/>
-          <p:cNvSpPr/>
-          <p:nvPr/>
-        </p:nvSpPr>
-        <p:spPr>
-          <a:xfrm>
-            <a:off x="777240" y="4601261"/>
-            <a:ext cx="10515600" cy="0"/>
-          </a:xfrm>
-          <a:prstGeom prst="line">
-            <a:avLst/>
-          </a:prstGeom>
-          <a:noFill/>
-          <a:ln w="9525">
-            <a:solidFill>
-              <a:srgbClr val="E0E0E0"/>
-            </a:solidFill>
-            <a:prstDash val="solid"/>
-          </a:ln>
-        </p:spPr>
-      </p:sp>
-      <p:sp>
-        <p:nvSpPr>
-          <p:cNvPr id="19" name="Shape 17"/>
-          <p:cNvSpPr/>
-          <p:nvPr/>
-        </p:nvSpPr>
-        <p:spPr>
-          <a:xfrm>
-            <a:off x="502920" y="4736592"/>
-            <a:ext cx="137160" cy="137160"/>
-          </a:xfrm>
-          <a:prstGeom prst="diamond">
-            <a:avLst/>
-          </a:prstGeom>
-          <a:solidFill>
-            <a:srgbClr val="C46D54"/>
-          </a:solidFill>
-          <a:ln/>
-        </p:spPr>
-      </p:sp>
-      <p:sp>
-        <p:nvSpPr>
-          <p:cNvPr id="20" name="Text 18"/>
-          <p:cNvSpPr/>
-          <p:nvPr/>
-        </p:nvSpPr>
-        <p:spPr>
-          <a:xfrm>
-            <a:off x="777240" y="4645152"/>
-            <a:ext cx="10515600" cy="790042"/>
-          </a:xfrm>
-          <a:prstGeom prst="rect">
-            <a:avLst/>
-          </a:prstGeom>
-          <a:noFill/>
-          <a:ln/>
-        </p:spPr>
-        <p:txBody>
-          <a:bodyPr wrap="square" rtlCol="0" anchor="t"/>
-          <a:lstStyle/>
-          <a:p>
-            <a:pPr indent="0" marL="0">
-              <a:buNone/>
-            </a:pPr>
-            <a:r>
-              <a:rPr lang="en-US" sz="1800" dirty="0">
-                <a:solidFill>
-                  <a:srgbClr val="444444"/>
-                </a:solidFill>
-                <a:latin typeface="Calibri" pitchFamily="34" charset="0"/>
-                <a:ea typeface="Calibri" pitchFamily="34" charset="-122"/>
-                <a:cs typeface="Calibri" pitchFamily="34" charset="-120"/>
-              </a:rPr>
-              <a:t>12 + 12 puntos — trazar paso a paso la cadena aceptada y explicar la rechazada</a:t>
-            </a:r>
-            <a:endParaRPr lang="en-US" sz="1800" dirty="0"/>
-          </a:p>
-        </p:txBody>
-      </p:sp>
-      <p:sp>
-        <p:nvSpPr>
-          <p:cNvPr id="21" name="Shape 19"/>
-          <p:cNvSpPr/>
-          <p:nvPr/>
-        </p:nvSpPr>
-        <p:spPr>
-          <a:xfrm>
-            <a:off x="777240" y="5479085"/>
-            <a:ext cx="10515600" cy="0"/>
-          </a:xfrm>
-          <a:prstGeom prst="line">
-            <a:avLst/>
-          </a:prstGeom>
-          <a:noFill/>
-          <a:ln w="9525">
-            <a:solidFill>
-              <a:srgbClr val="E0E0E0"/>
-            </a:solidFill>
-            <a:prstDash val="solid"/>
-          </a:ln>
-        </p:spPr>
-      </p:sp>
-      <p:sp>
-        <p:nvSpPr>
-          <p:cNvPr id="22" name="Shape 20"/>
-          <p:cNvSpPr/>
-          <p:nvPr/>
-        </p:nvSpPr>
-        <p:spPr>
-          <a:xfrm>
-            <a:off x="502920" y="5614416"/>
-            <a:ext cx="137160" cy="137160"/>
-          </a:xfrm>
-          <a:prstGeom prst="diamond">
-            <a:avLst/>
-          </a:prstGeom>
-          <a:solidFill>
-            <a:srgbClr val="C46D54"/>
-          </a:solidFill>
-          <a:ln/>
-        </p:spPr>
-      </p:sp>
-      <p:sp>
-        <p:nvSpPr>
-          <p:cNvPr id="23" name="Text 21"/>
-          <p:cNvSpPr/>
-          <p:nvPr/>
-        </p:nvSpPr>
-        <p:spPr>
-          <a:xfrm>
-            <a:off x="777240" y="5522976"/>
-            <a:ext cx="10515600" cy="790042"/>
-          </a:xfrm>
-          <a:prstGeom prst="rect">
-            <a:avLst/>
-          </a:prstGeom>
-          <a:noFill/>
-          <a:ln/>
-        </p:spPr>
-        <p:txBody>
-          <a:bodyPr wrap="square" rtlCol="0" anchor="t"/>
-          <a:lstStyle/>
-          <a:p>
-            <a:pPr indent="0" marL="0">
-              <a:buNone/>
-            </a:pPr>
-            <a:r>
-              <a:rPr lang="en-US" sz="1800" dirty="0">
-                <a:solidFill>
-                  <a:srgbClr val="444444"/>
-                </a:solidFill>
-                <a:latin typeface="Calibri" pitchFamily="34" charset="0"/>
-                <a:ea typeface="Calibri" pitchFamily="34" charset="-122"/>
-                <a:cs typeface="Calibri" pitchFamily="34" charset="-120"/>
-              </a:rPr>
-              <a:t>10 + 6 puntos — justificar el dominio y responder las preguntas del profesor con solvencia</a:t>
             </a:r>
             <a:endParaRPr lang="en-US" sz="1800" dirty="0"/>
           </a:p>

</xml_diff>

<commit_message>
fix: corregir lógica de turnos en traza aceptada
</commit_message>
<xml_diff>
--- a/Proyecto_PDA_Esgrima.pptx
+++ b/Proyecto_PDA_Esgrima.pptx
@@ -6277,7 +6277,7 @@
                 <a:ea typeface="Calibri" pitchFamily="34" charset="-122"/>
                 <a:cs typeface="Calibri" pitchFamily="34" charset="-120"/>
               </a:rPr>
-              <a:t>El atacante avanza hasta largo — el defensor falla la parada y no logra nada</a:t>
+              <a:t>El atacante avanza a largo — el defensor falla la parada y no logra nada</a:t>
             </a:r>
             <a:endParaRPr lang="en-US" sz="1800" dirty="0"/>
           </a:p>
@@ -6441,7 +6441,7 @@
                 <a:ea typeface="Calibri" pitchFamily="34" charset="-122"/>
                 <a:cs typeface="Calibri" pitchFamily="34" charset="-120"/>
               </a:rPr>
-              <a:t>El atacante re-avanza a medio, luego a corto, luego a corps-à-corps — la pila acumula todo el recorrido</a:t>
+              <a:t>El atacante re-avanza a medio y el defensor falla. Luego avanza a corto y el defensor falla de nuevo</a:t>
             </a:r>
             <a:endParaRPr lang="en-US" sz="1800" dirty="0"/>
           </a:p>
@@ -6523,7 +6523,7 @@
                 <a:ea typeface="Calibri" pitchFamily="34" charset="-122"/>
                 <a:cs typeface="Calibri" pitchFamily="34" charset="-120"/>
               </a:rPr>
-              <a:t>El defensor vuelve a fallar la parada — no puede detener el remate</a:t>
+              <a:t>El atacante avanza a corps-à-corps y el defensor falla su última parada, quedando sin opciones</a:t>
             </a:r>
             <a:endParaRPr lang="en-US" sz="1800" dirty="0"/>
           </a:p>

</xml_diff>

<commit_message>
feat: agregar cadenas de entrada a diapositivas de trazas
</commit_message>
<xml_diff>
--- a/Proyecto_PDA_Esgrima.pptx
+++ b/Proyecto_PDA_Esgrima.pptx
@@ -6253,7 +6253,7 @@
         <p:spPr>
           <a:xfrm>
             <a:off x="777240" y="2011680"/>
-            <a:ext cx="10515600" cy="790042"/>
+            <a:ext cx="10515600" cy="658368"/>
           </a:xfrm>
           <a:prstGeom prst="rect">
             <a:avLst/>
@@ -6277,7 +6277,7 @@
                 <a:ea typeface="Calibri" pitchFamily="34" charset="-122"/>
                 <a:cs typeface="Calibri" pitchFamily="34" charset="-120"/>
               </a:rPr>
-              <a:t>El atacante avanza a largo — el defensor falla la parada y no logra nada</a:t>
+              <a:t>Cadena (w): avance, parada_fallida, avance, retirada, avance, parada_fallida, avance, parada_fallida, avance, parada_fallida, tocado</a:t>
             </a:r>
             <a:endParaRPr lang="en-US" sz="1800" dirty="0"/>
           </a:p>
@@ -6291,7 +6291,7 @@
         </p:nvSpPr>
         <p:spPr>
           <a:xfrm>
-            <a:off x="777240" y="2845613"/>
+            <a:off x="777240" y="2706624"/>
             <a:ext cx="10515600" cy="0"/>
           </a:xfrm>
           <a:prstGeom prst="line">
@@ -6314,7 +6314,7 @@
         </p:nvSpPr>
         <p:spPr>
           <a:xfrm>
-            <a:off x="502920" y="2980944"/>
+            <a:off x="502920" y="2834640"/>
             <a:ext cx="137160" cy="137160"/>
           </a:xfrm>
           <a:prstGeom prst="diamond">
@@ -6334,8 +6334,8 @@
         </p:nvSpPr>
         <p:spPr>
           <a:xfrm>
-            <a:off x="777240" y="2889504"/>
-            <a:ext cx="10515600" cy="790042"/>
+            <a:off x="777240" y="2743200"/>
+            <a:ext cx="10515600" cy="658368"/>
           </a:xfrm>
           <a:prstGeom prst="rect">
             <a:avLst/>
@@ -6359,7 +6359,7 @@
                 <a:ea typeface="Calibri" pitchFamily="34" charset="-122"/>
                 <a:cs typeface="Calibri" pitchFamily="34" charset="-120"/>
               </a:rPr>
-              <a:t>El atacante avanza a medio — el defensor logra retroceder y lo empuja de vuelta a largo</a:t>
+              <a:t>El atacante avanza a largo — el defensor falla la parada y no logra nada</a:t>
             </a:r>
             <a:endParaRPr lang="en-US" sz="1800" dirty="0"/>
           </a:p>
@@ -6373,7 +6373,7 @@
         </p:nvSpPr>
         <p:spPr>
           <a:xfrm>
-            <a:off x="777240" y="3723437"/>
+            <a:off x="777240" y="3438144"/>
             <a:ext cx="10515600" cy="0"/>
           </a:xfrm>
           <a:prstGeom prst="line">
@@ -6396,7 +6396,7 @@
         </p:nvSpPr>
         <p:spPr>
           <a:xfrm>
-            <a:off x="502920" y="3858768"/>
+            <a:off x="502920" y="3566160"/>
             <a:ext cx="137160" cy="137160"/>
           </a:xfrm>
           <a:prstGeom prst="diamond">
@@ -6416,8 +6416,8 @@
         </p:nvSpPr>
         <p:spPr>
           <a:xfrm>
-            <a:off x="777240" y="3767328"/>
-            <a:ext cx="10515600" cy="790042"/>
+            <a:off x="777240" y="3474720"/>
+            <a:ext cx="10515600" cy="658368"/>
           </a:xfrm>
           <a:prstGeom prst="rect">
             <a:avLst/>
@@ -6441,7 +6441,7 @@
                 <a:ea typeface="Calibri" pitchFamily="34" charset="-122"/>
                 <a:cs typeface="Calibri" pitchFamily="34" charset="-120"/>
               </a:rPr>
-              <a:t>El atacante re-avanza a medio y el defensor falla. Luego avanza a corto y el defensor falla de nuevo</a:t>
+              <a:t>El atacante avanza a medio — el defensor logra retroceder y lo empuja de vuelta a largo</a:t>
             </a:r>
             <a:endParaRPr lang="en-US" sz="1800" dirty="0"/>
           </a:p>
@@ -6455,7 +6455,7 @@
         </p:nvSpPr>
         <p:spPr>
           <a:xfrm>
-            <a:off x="777240" y="4601261"/>
+            <a:off x="777240" y="4169664"/>
             <a:ext cx="10515600" cy="0"/>
           </a:xfrm>
           <a:prstGeom prst="line">
@@ -6478,7 +6478,7 @@
         </p:nvSpPr>
         <p:spPr>
           <a:xfrm>
-            <a:off x="502920" y="4736592"/>
+            <a:off x="502920" y="4297680"/>
             <a:ext cx="137160" cy="137160"/>
           </a:xfrm>
           <a:prstGeom prst="diamond">
@@ -6498,8 +6498,8 @@
         </p:nvSpPr>
         <p:spPr>
           <a:xfrm>
-            <a:off x="777240" y="4645152"/>
-            <a:ext cx="10515600" cy="790042"/>
+            <a:off x="777240" y="4206240"/>
+            <a:ext cx="10515600" cy="658368"/>
           </a:xfrm>
           <a:prstGeom prst="rect">
             <a:avLst/>
@@ -6523,7 +6523,7 @@
                 <a:ea typeface="Calibri" pitchFamily="34" charset="-122"/>
                 <a:cs typeface="Calibri" pitchFamily="34" charset="-120"/>
               </a:rPr>
-              <a:t>El atacante avanza a corps-à-corps y el defensor falla su última parada, quedando sin opciones</a:t>
+              <a:t>El atacante re-avanza a medio y el defensor falla. Luego avanza a corto y el defensor falla de nuevo</a:t>
             </a:r>
             <a:endParaRPr lang="en-US" sz="1800" dirty="0"/>
           </a:p>
@@ -6537,7 +6537,7 @@
         </p:nvSpPr>
         <p:spPr>
           <a:xfrm>
-            <a:off x="777240" y="5479085"/>
+            <a:off x="777240" y="4901184"/>
             <a:ext cx="10515600" cy="0"/>
           </a:xfrm>
           <a:prstGeom prst="line">
@@ -6560,7 +6560,7 @@
         </p:nvSpPr>
         <p:spPr>
           <a:xfrm>
-            <a:off x="502920" y="5614416"/>
+            <a:off x="502920" y="5029200"/>
             <a:ext cx="137160" cy="137160"/>
           </a:xfrm>
           <a:prstGeom prst="diamond">
@@ -6580,8 +6580,8 @@
         </p:nvSpPr>
         <p:spPr>
           <a:xfrm>
-            <a:off x="777240" y="5522976"/>
-            <a:ext cx="10515600" cy="790042"/>
+            <a:off x="777240" y="4937760"/>
+            <a:ext cx="10515600" cy="658368"/>
           </a:xfrm>
           <a:prstGeom prst="rect">
             <a:avLst/>
@@ -6605,6 +6605,88 @@
                 <a:ea typeface="Calibri" pitchFamily="34" charset="-122"/>
                 <a:cs typeface="Calibri" pitchFamily="34" charset="-120"/>
               </a:rPr>
+              <a:t>El atacante avanza a corps-à-corps y el defensor falla su última parada, quedando sin opciones</a:t>
+            </a:r>
+            <a:endParaRPr lang="en-US" sz="1800" dirty="0"/>
+          </a:p>
+        </p:txBody>
+      </p:sp>
+      <p:sp>
+        <p:nvSpPr>
+          <p:cNvPr id="24" name="Shape 22"/>
+          <p:cNvSpPr/>
+          <p:nvPr/>
+        </p:nvSpPr>
+        <p:spPr>
+          <a:xfrm>
+            <a:off x="777240" y="5632704"/>
+            <a:ext cx="10515600" cy="0"/>
+          </a:xfrm>
+          <a:prstGeom prst="line">
+            <a:avLst/>
+          </a:prstGeom>
+          <a:noFill/>
+          <a:ln w="9525">
+            <a:solidFill>
+              <a:srgbClr val="E0E0E0"/>
+            </a:solidFill>
+            <a:prstDash val="solid"/>
+          </a:ln>
+        </p:spPr>
+      </p:sp>
+      <p:sp>
+        <p:nvSpPr>
+          <p:cNvPr id="25" name="Shape 23"/>
+          <p:cNvSpPr/>
+          <p:nvPr/>
+        </p:nvSpPr>
+        <p:spPr>
+          <a:xfrm>
+            <a:off x="502920" y="5760720"/>
+            <a:ext cx="137160" cy="137160"/>
+          </a:xfrm>
+          <a:prstGeom prst="diamond">
+            <a:avLst/>
+          </a:prstGeom>
+          <a:solidFill>
+            <a:srgbClr val="C46D54"/>
+          </a:solidFill>
+          <a:ln/>
+        </p:spPr>
+      </p:sp>
+      <p:sp>
+        <p:nvSpPr>
+          <p:cNvPr id="26" name="Text 24"/>
+          <p:cNvSpPr/>
+          <p:nvPr/>
+        </p:nvSpPr>
+        <p:spPr>
+          <a:xfrm>
+            <a:off x="777240" y="5669280"/>
+            <a:ext cx="10515600" cy="658368"/>
+          </a:xfrm>
+          <a:prstGeom prst="rect">
+            <a:avLst/>
+          </a:prstGeom>
+          <a:noFill/>
+          <a:ln/>
+        </p:spPr>
+        <p:txBody>
+          <a:bodyPr wrap="square" rtlCol="0" anchor="t"/>
+          <a:lstStyle/>
+          <a:p>
+            <a:pPr indent="0" marL="0">
+              <a:buNone/>
+            </a:pPr>
+            <a:r>
+              <a:rPr lang="en-US" sz="1800" dirty="0">
+                <a:solidFill>
+                  <a:srgbClr val="444444"/>
+                </a:solidFill>
+                <a:latin typeface="Calibri" pitchFamily="34" charset="0"/>
+                <a:ea typeface="Calibri" pitchFamily="34" charset="-122"/>
+                <a:cs typeface="Calibri" pitchFamily="34" charset="-120"/>
+              </a:rPr>
               <a:t>El atacante ejecuta el tocado desde corps-à-corps — el autómata acepta, la cadena pertenece al lenguaje</a:t>
             </a:r>
             <a:endParaRPr lang="en-US" sz="1800" dirty="0"/>
@@ -6613,7 +6695,7 @@
       </p:sp>
       <p:sp>
         <p:nvSpPr>
-          <p:cNvPr id="24" name="Shape 22"/>
+          <p:cNvPr id="27" name="Shape 25"/>
           <p:cNvSpPr/>
           <p:nvPr/>
         </p:nvSpPr>
@@ -6633,7 +6715,7 @@
       </p:sp>
       <p:sp>
         <p:nvSpPr>
-          <p:cNvPr id="25" name="Text 23"/>
+          <p:cNvPr id="28" name="Text 26"/>
           <p:cNvSpPr/>
           <p:nvPr/>
         </p:nvSpPr>
@@ -6963,7 +7045,7 @@
         <p:spPr>
           <a:xfrm>
             <a:off x="777240" y="2011680"/>
-            <a:ext cx="10515600" cy="790042"/>
+            <a:ext cx="10515600" cy="658368"/>
           </a:xfrm>
           <a:prstGeom prst="rect">
             <a:avLst/>
@@ -6987,7 +7069,7 @@
                 <a:ea typeface="Calibri" pitchFamily="34" charset="-122"/>
                 <a:cs typeface="Calibri" pitchFamily="34" charset="-120"/>
               </a:rPr>
-              <a:t>El atacante avanza hasta largo — primer movimiento válido</a:t>
+              <a:t>Cadena (w): avance, retirada, tocado</a:t>
             </a:r>
             <a:endParaRPr lang="en-US" sz="1800" dirty="0"/>
           </a:p>
@@ -7001,7 +7083,7 @@
         </p:nvSpPr>
         <p:spPr>
           <a:xfrm>
-            <a:off x="777240" y="2845613"/>
+            <a:off x="777240" y="2706624"/>
             <a:ext cx="10515600" cy="0"/>
           </a:xfrm>
           <a:prstGeom prst="line">
@@ -7024,7 +7106,7 @@
         </p:nvSpPr>
         <p:spPr>
           <a:xfrm>
-            <a:off x="502920" y="2980944"/>
+            <a:off x="502920" y="2834640"/>
             <a:ext cx="137160" cy="137160"/>
           </a:xfrm>
           <a:prstGeom prst="diamond">
@@ -7044,8 +7126,8 @@
         </p:nvSpPr>
         <p:spPr>
           <a:xfrm>
-            <a:off x="777240" y="2889504"/>
-            <a:ext cx="10515600" cy="790042"/>
+            <a:off x="777240" y="2743200"/>
+            <a:ext cx="10515600" cy="658368"/>
           </a:xfrm>
           <a:prstGeom prst="rect">
             <a:avLst/>
@@ -7069,7 +7151,7 @@
                 <a:ea typeface="Calibri" pitchFamily="34" charset="-122"/>
                 <a:cs typeface="Calibri" pitchFamily="34" charset="-120"/>
               </a:rPr>
-              <a:t>El defensor logra retroceder — empuja al atacante de vuelta a la posición de guardia inicial</a:t>
+              <a:t>El atacante avanza hasta largo — primer movimiento válido</a:t>
             </a:r>
             <a:endParaRPr lang="en-US" sz="1800" dirty="0"/>
           </a:p>
@@ -7083,7 +7165,7 @@
         </p:nvSpPr>
         <p:spPr>
           <a:xfrm>
-            <a:off x="777240" y="3723437"/>
+            <a:off x="777240" y="3438144"/>
             <a:ext cx="10515600" cy="0"/>
           </a:xfrm>
           <a:prstGeom prst="line">
@@ -7106,7 +7188,7 @@
         </p:nvSpPr>
         <p:spPr>
           <a:xfrm>
-            <a:off x="502920" y="3858768"/>
+            <a:off x="502920" y="3566160"/>
             <a:ext cx="137160" cy="137160"/>
           </a:xfrm>
           <a:prstGeom prst="diamond">
@@ -7126,8 +7208,8 @@
         </p:nvSpPr>
         <p:spPr>
           <a:xfrm>
-            <a:off x="777240" y="3767328"/>
-            <a:ext cx="10515600" cy="790042"/>
+            <a:off x="777240" y="3474720"/>
+            <a:ext cx="10515600" cy="658368"/>
           </a:xfrm>
           <a:prstGeom prst="rect">
             <a:avLst/>
@@ -7151,7 +7233,7 @@
                 <a:ea typeface="Calibri" pitchFamily="34" charset="-122"/>
                 <a:cs typeface="Calibri" pitchFamily="34" charset="-120"/>
               </a:rPr>
-              <a:t>El atacante intenta hacer el tocado estando en la guardia inicial — esa acción no existe en la tabla</a:t>
+              <a:t>El defensor logra retroceder — empuja al atacante de vuelta a la posición de guardia inicial</a:t>
             </a:r>
             <a:endParaRPr lang="en-US" sz="1800" dirty="0"/>
           </a:p>
@@ -7165,7 +7247,7 @@
         </p:nvSpPr>
         <p:spPr>
           <a:xfrm>
-            <a:off x="777240" y="4601261"/>
+            <a:off x="777240" y="4169664"/>
             <a:ext cx="10515600" cy="0"/>
           </a:xfrm>
           <a:prstGeom prst="line">
@@ -7188,7 +7270,7 @@
         </p:nvSpPr>
         <p:spPr>
           <a:xfrm>
-            <a:off x="502920" y="4736592"/>
+            <a:off x="502920" y="4297680"/>
             <a:ext cx="137160" cy="137160"/>
           </a:xfrm>
           <a:prstGeom prst="diamond">
@@ -7208,8 +7290,8 @@
         </p:nvSpPr>
         <p:spPr>
           <a:xfrm>
-            <a:off x="777240" y="4645152"/>
-            <a:ext cx="10515600" cy="790042"/>
+            <a:off x="777240" y="4206240"/>
+            <a:ext cx="10515600" cy="658368"/>
           </a:xfrm>
           <a:prstGeom prst="rect">
             <a:avLst/>
@@ -7233,7 +7315,7 @@
                 <a:ea typeface="Calibri" pitchFamily="34" charset="-122"/>
                 <a:cs typeface="Calibri" pitchFamily="34" charset="-120"/>
               </a:rPr>
-              <a:t>El autómata rechaza inmediatamente: no hay transición definida para esa situación</a:t>
+              <a:t>El atacante intenta hacer el tocado estando en la guardia inicial — esa acción no existe en la tabla</a:t>
             </a:r>
             <a:endParaRPr lang="en-US" sz="1800" dirty="0"/>
           </a:p>
@@ -7247,7 +7329,7 @@
         </p:nvSpPr>
         <p:spPr>
           <a:xfrm>
-            <a:off x="777240" y="5479085"/>
+            <a:off x="777240" y="4901184"/>
             <a:ext cx="10515600" cy="0"/>
           </a:xfrm>
           <a:prstGeom prst="line">
@@ -7270,7 +7352,7 @@
         </p:nvSpPr>
         <p:spPr>
           <a:xfrm>
-            <a:off x="502920" y="5614416"/>
+            <a:off x="502920" y="5029200"/>
             <a:ext cx="137160" cy="137160"/>
           </a:xfrm>
           <a:prstGeom prst="diamond">
@@ -7290,8 +7372,8 @@
         </p:nvSpPr>
         <p:spPr>
           <a:xfrm>
-            <a:off x="777240" y="5522976"/>
-            <a:ext cx="10515600" cy="790042"/>
+            <a:off x="777240" y="4937760"/>
+            <a:ext cx="10515600" cy="658368"/>
           </a:xfrm>
           <a:prstGeom prst="rect">
             <a:avLst/>
@@ -7315,6 +7397,88 @@
                 <a:ea typeface="Calibri" pitchFamily="34" charset="-122"/>
                 <a:cs typeface="Calibri" pitchFamily="34" charset="-120"/>
               </a:rPr>
+              <a:t>El autómata rechaza inmediatamente: no hay transición definida para esa situación</a:t>
+            </a:r>
+            <a:endParaRPr lang="en-US" sz="1800" dirty="0"/>
+          </a:p>
+        </p:txBody>
+      </p:sp>
+      <p:sp>
+        <p:nvSpPr>
+          <p:cNvPr id="24" name="Shape 22"/>
+          <p:cNvSpPr/>
+          <p:nvPr/>
+        </p:nvSpPr>
+        <p:spPr>
+          <a:xfrm>
+            <a:off x="777240" y="5632704"/>
+            <a:ext cx="10515600" cy="0"/>
+          </a:xfrm>
+          <a:prstGeom prst="line">
+            <a:avLst/>
+          </a:prstGeom>
+          <a:noFill/>
+          <a:ln w="9525">
+            <a:solidFill>
+              <a:srgbClr val="E0E0E0"/>
+            </a:solidFill>
+            <a:prstDash val="solid"/>
+          </a:ln>
+        </p:spPr>
+      </p:sp>
+      <p:sp>
+        <p:nvSpPr>
+          <p:cNvPr id="25" name="Shape 23"/>
+          <p:cNvSpPr/>
+          <p:nvPr/>
+        </p:nvSpPr>
+        <p:spPr>
+          <a:xfrm>
+            <a:off x="502920" y="5760720"/>
+            <a:ext cx="137160" cy="137160"/>
+          </a:xfrm>
+          <a:prstGeom prst="diamond">
+            <a:avLst/>
+          </a:prstGeom>
+          <a:solidFill>
+            <a:srgbClr val="C46D54"/>
+          </a:solidFill>
+          <a:ln/>
+        </p:spPr>
+      </p:sp>
+      <p:sp>
+        <p:nvSpPr>
+          <p:cNvPr id="26" name="Text 24"/>
+          <p:cNvSpPr/>
+          <p:nvPr/>
+        </p:nvSpPr>
+        <p:spPr>
+          <a:xfrm>
+            <a:off x="777240" y="5669280"/>
+            <a:ext cx="10515600" cy="658368"/>
+          </a:xfrm>
+          <a:prstGeom prst="rect">
+            <a:avLst/>
+          </a:prstGeom>
+          <a:noFill/>
+          <a:ln/>
+        </p:spPr>
+        <p:txBody>
+          <a:bodyPr wrap="square" rtlCol="0" anchor="t"/>
+          <a:lstStyle/>
+          <a:p>
+            <a:pPr indent="0" marL="0">
+              <a:buNone/>
+            </a:pPr>
+            <a:r>
+              <a:rPr lang="en-US" sz="1800" dirty="0">
+                <a:solidFill>
+                  <a:srgbClr val="444444"/>
+                </a:solidFill>
+                <a:latin typeface="Calibri" pitchFamily="34" charset="0"/>
+                <a:ea typeface="Calibri" pitchFamily="34" charset="-122"/>
+                <a:cs typeface="Calibri" pitchFamily="34" charset="-120"/>
+              </a:rPr>
               <a:t>Razón: el tocado solo es válido desde corps-à-corps — intentarlo desde la guardia es inválido</a:t>
             </a:r>
             <a:endParaRPr lang="en-US" sz="1800" dirty="0"/>
@@ -7323,7 +7487,7 @@
       </p:sp>
       <p:sp>
         <p:nvSpPr>
-          <p:cNvPr id="24" name="Shape 22"/>
+          <p:cNvPr id="27" name="Shape 25"/>
           <p:cNvSpPr/>
           <p:nvPr/>
         </p:nvSpPr>
@@ -7343,7 +7507,7 @@
       </p:sp>
       <p:sp>
         <p:nvSpPr>
-          <p:cNvPr id="25" name="Text 23"/>
+          <p:cNvPr id="28" name="Text 26"/>
           <p:cNvSpPr/>
           <p:nvPr/>
         </p:nvSpPr>

</xml_diff>